<commit_message>
Refactor presentation rendering into processor architecture
</commit_message>
<xml_diff>
--- a/output/test_builder.pptx
+++ b/output/test_builder.pptx
@@ -3226,7 +3226,7 @@
                 </a:solidFill>
                 <a:latin typeface="Poppins ExtraBold"/>
               </a:rPr>
-              <a:t>Circuit</a:t>
+              <a:t>cultivate</a:t>
             </a:r>
             <a:endParaRPr sz="6600" b="0" i="0" u="none" dirty="0">
               <a:solidFill>
@@ -3267,7 +3267,7 @@
                 </a:solidFill>
                 <a:latin typeface="Poppins"/>
               </a:rPr>
-              <a:t>A complete closed path through which electric current can flow.</a:t>
+              <a:t>To prepare and use land for growing crops or plants.</a:t>
             </a:r>
             <a:endParaRPr sz="2000" b="1" i="0" u="none" dirty="0">
               <a:solidFill>
@@ -3360,7 +3360,7 @@
                 </a:solidFill>
                 <a:latin typeface="Noto Sans SemiBold"/>
               </a:rPr>
-              <a:t/>
+              <a:t>cultivate</a:t>
             </a:r>
             <a:r>
               <a:rPr sz="2000" b="1" dirty="0">
@@ -3392,7 +3392,7 @@
                 </a:solidFill>
                 <a:latin typeface="Noto Sans SemiBold"/>
               </a:rPr>
-              <a:t/>
+              <a:t>cultivates</a:t>
             </a:r>
             <a:r>
               <a:rPr sz="2000" b="1" dirty="0">
@@ -3424,7 +3424,7 @@
                 </a:solidFill>
                 <a:latin typeface="Noto Sans SemiBold"/>
               </a:rPr>
-              <a:t/>
+              <a:t>cultivated</a:t>
             </a:r>
             <a:endParaRPr sz="2000" b="1" dirty="0">
               <a:solidFill>
@@ -3470,7 +3470,7 @@
                   <a:srgbClr val="475569"/>
                 </a:solidFill>
               </a:rPr>
-              <a:t>परिपथ,</a:t>
+              <a:t>जोतना,</a:t>
             </a:r>
           </a:p>
           <a:p>
@@ -3481,7 +3481,7 @@
                   <a:srgbClr val="475569"/>
                 </a:solidFill>
               </a:rPr>
-              <a:t> സർക്യൂട്ട്,</a:t>
+              <a:t> കൃഷിചെയ്യുക,</a:t>
             </a:r>
             <a:br>
               <a:rPr lang="en-GB" b="1" dirty="0">
@@ -3496,7 +3496,7 @@
                   <a:srgbClr val="475569"/>
                 </a:solidFill>
               </a:rPr>
-              <a:t>மின்சுற்று</a:t>
+              <a:t>பயிரிடு</a:t>
             </a:r>
             <a:endParaRPr lang="en-IN" b="1" dirty="0">
               <a:solidFill>
@@ -3586,7 +3586,7 @@
                 </a:solidFill>
                 <a:latin typeface="Poppins ExtraBold"/>
               </a:rPr>
-              <a:t>/ˈsɜːrkɪt/</a:t>
+              <a:t>/ˈkʌl.tɪ.veɪt/</a:t>
             </a:r>
             <a:endParaRPr sz="1650" u="none" dirty="0">
               <a:solidFill>
@@ -3740,7 +3740,7 @@
                 </a:solidFill>
                 <a:latin typeface="Poppins ExtraBold"/>
               </a:rPr>
-              <a:t>/kənˈdʌk.tər/</a:t>
+              <a:t>/ˌɪr.əˈɡeɪ.ʃən/</a:t>
             </a:r>
             <a:endParaRPr sz="1650" u="none" dirty="0">
               <a:solidFill>
@@ -3815,7 +3815,7 @@
                 </a:solidFill>
                 <a:latin typeface="Poppins ExtraBold"/>
               </a:rPr>
-              <a:t>Conductor</a:t>
+              <a:t>irrigation</a:t>
             </a:r>
             <a:endParaRPr sz="6600" b="0" i="0" u="none" dirty="0">
               <a:solidFill>
@@ -3862,7 +3862,7 @@
                 </a:solidFill>
                 <a:latin typeface="Poppins"/>
               </a:rPr>
-              <a:t>A material or device that allows electricity to flow through easily.</a:t>
+              <a:t>The supply of water to land or crops to help growth.</a:t>
             </a:r>
             <a:endParaRPr sz="2000" b="1" i="0" u="none" dirty="0">
               <a:solidFill>
@@ -4047,7 +4047,7 @@
                 </a:solidFill>
                 <a:latin typeface="Poppins ExtraBold"/>
               </a:rPr>
-              <a:t>The scientist discovered that the new metal acted as an efficient conductor.</a:t>
+              <a:t>The old irrigation system supplied water to all farms in the valley.</a:t>
             </a:r>
             <a:endParaRPr sz="2400" b="0" i="0" u="none" dirty="0">
               <a:solidFill>
@@ -4137,7 +4137,7 @@
                   <a:srgbClr val="475569"/>
                 </a:solidFill>
               </a:rPr>
-              <a:t>चालक,</a:t>
+              <a:t>सिंचाई,</a:t>
             </a:r>
           </a:p>
           <a:p>
@@ -4148,7 +4148,7 @@
                   <a:srgbClr val="475569"/>
                 </a:solidFill>
               </a:rPr>
-              <a:t> ചാലകം,</a:t>
+              <a:t> ജലസേചനം,</a:t>
             </a:r>
             <a:br>
               <a:rPr lang="en-GB" b="1" dirty="0">
@@ -4163,7 +4163,7 @@
                   <a:srgbClr val="475569"/>
                 </a:solidFill>
               </a:rPr>
-              <a:t>கடத்தி</a:t>
+              <a:t>பாசனம்</a:t>
             </a:r>
             <a:endParaRPr lang="en-IN" b="1" dirty="0">
               <a:solidFill>
@@ -4316,7 +4316,7 @@
                 </a:solidFill>
                 <a:latin typeface="Poppins ExtraBold"/>
               </a:rPr>
-              <a:t>/kənˈdʌk.tər/</a:t>
+              <a:t>/ˌɪr.əˈɡeɪ.ʃən/</a:t>
             </a:r>
             <a:endParaRPr sz="1650" u="none" dirty="0">
               <a:solidFill>
@@ -4391,7 +4391,7 @@
                 </a:solidFill>
                 <a:latin typeface="Poppins ExtraBold"/>
               </a:rPr>
-              <a:t>Conductor</a:t>
+              <a:t>irrigation</a:t>
             </a:r>
             <a:endParaRPr sz="6600" b="0" i="0" u="none" dirty="0">
               <a:solidFill>
@@ -4438,7 +4438,7 @@
                 </a:solidFill>
                 <a:latin typeface="Poppins"/>
               </a:rPr>
-              <a:t>A material or device that allows electricity to flow through easily.</a:t>
+              <a:t>The supply of water to land or crops to help growth.</a:t>
             </a:r>
             <a:endParaRPr sz="2000" b="1" i="0" u="none" dirty="0">
               <a:solidFill>
@@ -4623,7 +4623,7 @@
                 </a:solidFill>
                 <a:latin typeface="Poppins ExtraBold"/>
               </a:rPr>
-              <a:t>The scientist discovered that the new metal acted as an efficient conductor.</a:t>
+              <a:t>The old irrigation system supplied water to all farms in the valley.</a:t>
             </a:r>
             <a:endParaRPr sz="2400" b="0" i="0" u="none" dirty="0">
               <a:solidFill>
@@ -4668,7 +4668,7 @@
                   <a:srgbClr val="2A3644"/>
                 </a:solidFill>
               </a:rPr>
-              <a:t>Copper is a good conductor that carries electricity safely in homes.</a:t>
+              <a:t>Modern irrigation provides enough water for crops during dry weather conditions.</a:t>
             </a:r>
             <a:endParaRPr lang="en-IN" sz="2400" b="1" dirty="0">
               <a:solidFill>
@@ -4757,7 +4757,7 @@
                   <a:srgbClr val="475569"/>
                 </a:solidFill>
               </a:rPr>
-              <a:t>चालक,</a:t>
+              <a:t>सिंचाई,</a:t>
             </a:r>
           </a:p>
           <a:p>
@@ -4768,7 +4768,7 @@
                   <a:srgbClr val="475569"/>
                 </a:solidFill>
               </a:rPr>
-              <a:t> ചാലകം,</a:t>
+              <a:t> ജലസേചനം,</a:t>
             </a:r>
             <a:br>
               <a:rPr lang="en-GB" b="1" dirty="0">
@@ -4783,7 +4783,7 @@
                   <a:srgbClr val="475569"/>
                 </a:solidFill>
               </a:rPr>
-              <a:t>கடத்தி</a:t>
+              <a:t>பாசனம்</a:t>
             </a:r>
             <a:endParaRPr lang="en-IN" b="1" dirty="0">
               <a:solidFill>
@@ -4936,7 +4936,7 @@
                 </a:solidFill>
                 <a:latin typeface="Poppins ExtraBold"/>
               </a:rPr>
-              <a:t>/kənˈdʌk.tər/</a:t>
+              <a:t>/ˌɪr.əˈɡeɪ.ʃən/</a:t>
             </a:r>
             <a:endParaRPr sz="1650" u="none" dirty="0">
               <a:solidFill>
@@ -5011,7 +5011,7 @@
                 </a:solidFill>
                 <a:latin typeface="Poppins ExtraBold"/>
               </a:rPr>
-              <a:t>Conductor</a:t>
+              <a:t>irrigation</a:t>
             </a:r>
             <a:endParaRPr sz="6600" b="0" i="0" u="none" dirty="0">
               <a:solidFill>
@@ -5058,7 +5058,7 @@
                 </a:solidFill>
                 <a:latin typeface="Poppins"/>
               </a:rPr>
-              <a:t>A material or device that allows electricity to flow through easily.</a:t>
+              <a:t>The supply of water to land or crops to help growth.</a:t>
             </a:r>
             <a:endParaRPr sz="2000" b="1" i="0" u="none" dirty="0">
               <a:solidFill>
@@ -5243,7 +5243,7 @@
                 </a:solidFill>
                 <a:latin typeface="Poppins ExtraBold"/>
               </a:rPr>
-              <a:t>The scientist discovered that the new metal acted as an efficient conductor.</a:t>
+              <a:t>The old irrigation system supplied water to all farms in the valley.</a:t>
             </a:r>
             <a:endParaRPr sz="2400" b="0" i="0" u="none" dirty="0">
               <a:solidFill>
@@ -5288,7 +5288,7 @@
                   <a:srgbClr val="2A3644"/>
                 </a:solidFill>
               </a:rPr>
-              <a:t>Copper is a good conductor that carries electricity safely in homes.</a:t>
+              <a:t>Modern irrigation provides enough water for crops during dry weather conditions.</a:t>
             </a:r>
             <a:endParaRPr lang="en-IN" sz="2400" b="1" dirty="0">
               <a:solidFill>
@@ -5332,7 +5332,7 @@
                   <a:srgbClr val="2A3644"/>
                 </a:solidFill>
               </a:rPr>
-              <a:t>Engineers will use a flexible conductor for the upcoming smart wearable devices.</a:t>
+              <a:t>A new irrigation project will help farmers grow crops during dry summer.</a:t>
             </a:r>
             <a:endParaRPr lang="en-IN" sz="2400" b="1" dirty="0">
               <a:solidFill>
@@ -5421,7 +5421,7 @@
                   <a:srgbClr val="475569"/>
                 </a:solidFill>
               </a:rPr>
-              <a:t>चालक,</a:t>
+              <a:t>सिंचाई,</a:t>
             </a:r>
           </a:p>
           <a:p>
@@ -5432,7 +5432,7 @@
                   <a:srgbClr val="475569"/>
                 </a:solidFill>
               </a:rPr>
-              <a:t> ചാലകം,</a:t>
+              <a:t> ജലസേചനം,</a:t>
             </a:r>
             <a:br>
               <a:rPr lang="en-GB" b="1" dirty="0">
@@ -5447,7 +5447,7 @@
                   <a:srgbClr val="475569"/>
                 </a:solidFill>
               </a:rPr>
-              <a:t>கடத்தி</a:t>
+              <a:t>பாசனம்</a:t>
             </a:r>
             <a:endParaRPr lang="en-IN" b="1" dirty="0">
               <a:solidFill>
@@ -5627,7 +5627,7 @@
                 </a:solidFill>
                 <a:latin typeface="Poppins ExtraBold"/>
               </a:rPr>
-              <a:t>/ˈsɜːrkɪt/</a:t>
+              <a:t>/ˈkʌl.tɪ.veɪt/</a:t>
             </a:r>
             <a:endParaRPr sz="1650" u="none" dirty="0">
               <a:solidFill>
@@ -5708,7 +5708,7 @@
                 </a:solidFill>
                 <a:latin typeface="Poppins ExtraBold"/>
               </a:rPr>
-              <a:t>Circuit</a:t>
+              <a:t>cultivate</a:t>
             </a:r>
             <a:endParaRPr sz="6600" b="0" i="0" u="none" dirty="0">
               <a:solidFill>
@@ -5755,7 +5755,7 @@
                 </a:solidFill>
                 <a:latin typeface="Poppins"/>
               </a:rPr>
-              <a:t>A complete closed path through which electric current can flow.</a:t>
+              <a:t>To prepare and use land for growing crops or plants.</a:t>
             </a:r>
             <a:endParaRPr sz="2000" b="1" i="0" u="none" dirty="0">
               <a:solidFill>
@@ -5848,7 +5848,7 @@
                 </a:solidFill>
                 <a:latin typeface="Noto Sans SemiBold"/>
               </a:rPr>
-              <a:t/>
+              <a:t>cultivate</a:t>
             </a:r>
             <a:r>
               <a:rPr sz="2000" b="1" dirty="0">
@@ -5880,7 +5880,7 @@
                 </a:solidFill>
                 <a:latin typeface="Noto Sans SemiBold"/>
               </a:rPr>
-              <a:t/>
+              <a:t>cultivates</a:t>
             </a:r>
             <a:r>
               <a:rPr sz="2000" b="1" dirty="0">
@@ -5912,7 +5912,7 @@
                 </a:solidFill>
                 <a:latin typeface="Noto Sans SemiBold"/>
               </a:rPr>
-              <a:t/>
+              <a:t>cultivated</a:t>
             </a:r>
             <a:endParaRPr sz="2000" b="1" dirty="0">
               <a:solidFill>
@@ -5958,7 +5958,7 @@
                 </a:solidFill>
                 <a:latin typeface="Poppins ExtraBold"/>
               </a:rPr>
-              <a:t>He designed a complex circuit board for the new smartphone yesterday.</a:t>
+              <a:t>The local family cultivated organic vegetables on their small farm last year.</a:t>
             </a:r>
             <a:endParaRPr sz="2400" b="0" i="0" u="none" dirty="0">
               <a:solidFill>
@@ -6048,7 +6048,7 @@
                   <a:srgbClr val="475569"/>
                 </a:solidFill>
               </a:rPr>
-              <a:t>परिपथ,</a:t>
+              <a:t>जोतना,</a:t>
             </a:r>
           </a:p>
           <a:p>
@@ -6059,7 +6059,7 @@
                   <a:srgbClr val="475569"/>
                 </a:solidFill>
               </a:rPr>
-              <a:t> സർക്യൂട്ട്,</a:t>
+              <a:t> കൃഷിചെയ്യുക,</a:t>
             </a:r>
             <a:br>
               <a:rPr lang="en-GB" b="1" dirty="0">
@@ -6074,7 +6074,7 @@
                   <a:srgbClr val="475569"/>
                 </a:solidFill>
               </a:rPr>
-              <a:t>மின்சுற்று</a:t>
+              <a:t>பயிரிடு</a:t>
             </a:r>
             <a:endParaRPr lang="en-IN" b="1" dirty="0">
               <a:solidFill>
@@ -6259,7 +6259,7 @@
                 </a:solidFill>
                 <a:latin typeface="Poppins ExtraBold"/>
               </a:rPr>
-              <a:t>/ˈsɜːrkɪt/</a:t>
+              <a:t>/ˈkʌl.tɪ.veɪt/</a:t>
             </a:r>
             <a:endParaRPr sz="1650" u="none" dirty="0">
               <a:solidFill>
@@ -6340,7 +6340,7 @@
                 </a:solidFill>
                 <a:latin typeface="Poppins ExtraBold"/>
               </a:rPr>
-              <a:t>Circuit</a:t>
+              <a:t>cultivate</a:t>
             </a:r>
             <a:endParaRPr sz="6600" b="0" i="0" u="none" dirty="0">
               <a:solidFill>
@@ -6387,7 +6387,7 @@
                 </a:solidFill>
                 <a:latin typeface="Poppins"/>
               </a:rPr>
-              <a:t>A complete closed path through which electric current can flow.</a:t>
+              <a:t>To prepare and use land for growing crops or plants.</a:t>
             </a:r>
             <a:endParaRPr sz="2000" b="1" i="0" u="none" dirty="0">
               <a:solidFill>
@@ -6480,7 +6480,7 @@
                 </a:solidFill>
                 <a:latin typeface="Noto Sans SemiBold"/>
               </a:rPr>
-              <a:t/>
+              <a:t>cultivate</a:t>
             </a:r>
             <a:r>
               <a:rPr sz="2000" b="1" dirty="0">
@@ -6512,7 +6512,7 @@
                 </a:solidFill>
                 <a:latin typeface="Noto Sans SemiBold"/>
               </a:rPr>
-              <a:t/>
+              <a:t>cultivates</a:t>
             </a:r>
             <a:r>
               <a:rPr sz="2000" b="1" dirty="0">
@@ -6544,7 +6544,7 @@
                 </a:solidFill>
                 <a:latin typeface="Noto Sans SemiBold"/>
               </a:rPr>
-              <a:t/>
+              <a:t>cultivated</a:t>
             </a:r>
             <a:endParaRPr sz="2000" b="1" dirty="0">
               <a:solidFill>
@@ -6590,7 +6590,7 @@
                 </a:solidFill>
                 <a:latin typeface="Poppins ExtraBold"/>
               </a:rPr>
-              <a:t>He designed a complex circuit board for the new smartphone yesterday.</a:t>
+              <a:t>The local family cultivated organic vegetables on their small farm last year.</a:t>
             </a:r>
             <a:endParaRPr sz="2400" b="0" i="0" u="none" dirty="0">
               <a:solidFill>
@@ -6635,7 +6635,7 @@
                   <a:srgbClr val="2A3644"/>
                 </a:solidFill>
               </a:rPr>
-              <a:t>The engineer checks the circuit to fix the broken electrical connection.</a:t>
+              <a:t>Farmers cultivate the fertile soil every spring to prepare for planting crops.</a:t>
             </a:r>
             <a:endParaRPr lang="en-IN" sz="2400" b="1" dirty="0">
               <a:solidFill>
@@ -6724,7 +6724,7 @@
                   <a:srgbClr val="475569"/>
                 </a:solidFill>
               </a:rPr>
-              <a:t>परिपथ,</a:t>
+              <a:t>जोतना,</a:t>
             </a:r>
           </a:p>
           <a:p>
@@ -6735,7 +6735,7 @@
                   <a:srgbClr val="475569"/>
                 </a:solidFill>
               </a:rPr>
-              <a:t> സർക്യൂട്ട്,</a:t>
+              <a:t> കൃഷിചെയ്യുക,</a:t>
             </a:r>
             <a:br>
               <a:rPr lang="en-GB" b="1" dirty="0">
@@ -6750,7 +6750,7 @@
                   <a:srgbClr val="475569"/>
                 </a:solidFill>
               </a:rPr>
-              <a:t>மின்சுற்று</a:t>
+              <a:t>பயிரிடு</a:t>
             </a:r>
             <a:endParaRPr lang="en-IN" b="1" dirty="0">
               <a:solidFill>
@@ -6935,7 +6935,7 @@
                 </a:solidFill>
                 <a:latin typeface="Poppins ExtraBold"/>
               </a:rPr>
-              <a:t>/ˈsɜːrkɪt/</a:t>
+              <a:t>/ˈkʌl.tɪ.veɪt/</a:t>
             </a:r>
             <a:endParaRPr sz="1650" u="none" dirty="0">
               <a:solidFill>
@@ -7016,7 +7016,7 @@
                 </a:solidFill>
                 <a:latin typeface="Poppins ExtraBold"/>
               </a:rPr>
-              <a:t>Circuit</a:t>
+              <a:t>cultivate</a:t>
             </a:r>
             <a:endParaRPr sz="6600" b="0" i="0" u="none" dirty="0">
               <a:solidFill>
@@ -7063,7 +7063,7 @@
                 </a:solidFill>
                 <a:latin typeface="Poppins"/>
               </a:rPr>
-              <a:t>A complete closed path through which electric current can flow.</a:t>
+              <a:t>To prepare and use land for growing crops or plants.</a:t>
             </a:r>
             <a:endParaRPr sz="2000" b="1" i="0" u="none" dirty="0">
               <a:solidFill>
@@ -7156,7 +7156,7 @@
                 </a:solidFill>
                 <a:latin typeface="Noto Sans SemiBold"/>
               </a:rPr>
-              <a:t/>
+              <a:t>cultivate</a:t>
             </a:r>
             <a:r>
               <a:rPr sz="2000" b="1" dirty="0">
@@ -7188,7 +7188,7 @@
                 </a:solidFill>
                 <a:latin typeface="Noto Sans SemiBold"/>
               </a:rPr>
-              <a:t/>
+              <a:t>cultivates</a:t>
             </a:r>
             <a:r>
               <a:rPr sz="2000" b="1" dirty="0">
@@ -7220,7 +7220,7 @@
                 </a:solidFill>
                 <a:latin typeface="Noto Sans SemiBold"/>
               </a:rPr>
-              <a:t/>
+              <a:t>cultivated</a:t>
             </a:r>
             <a:endParaRPr sz="2000" b="1" dirty="0">
               <a:solidFill>
@@ -7266,7 +7266,7 @@
                 </a:solidFill>
                 <a:latin typeface="Poppins ExtraBold"/>
               </a:rPr>
-              <a:t>He designed a complex circuit board for the new smartphone yesterday.</a:t>
+              <a:t>The local family cultivated organic vegetables on their small farm last year.</a:t>
             </a:r>
             <a:endParaRPr sz="2400" b="0" i="0" u="none" dirty="0">
               <a:solidFill>
@@ -7311,7 +7311,7 @@
                   <a:srgbClr val="2A3644"/>
                 </a:solidFill>
               </a:rPr>
-              <a:t>The engineer checks the circuit to fix the broken electrical connection.</a:t>
+              <a:t>Farmers cultivate the fertile soil every spring to prepare for planting crops.</a:t>
             </a:r>
             <a:endParaRPr lang="en-IN" sz="2400" b="1" dirty="0">
               <a:solidFill>
@@ -7355,7 +7355,7 @@
                   <a:srgbClr val="2A3644"/>
                 </a:solidFill>
               </a:rPr>
-              <a:t>The technician will test the main circuit before turning on the power.</a:t>
+              <a:t>Next season, our community will cultivate a large field of sweet corn.</a:t>
             </a:r>
             <a:endParaRPr lang="en-IN" sz="2400" b="1" dirty="0">
               <a:solidFill>
@@ -7444,7 +7444,7 @@
                   <a:srgbClr val="475569"/>
                 </a:solidFill>
               </a:rPr>
-              <a:t>परिपथ,</a:t>
+              <a:t>जोतना,</a:t>
             </a:r>
           </a:p>
           <a:p>
@@ -7455,7 +7455,7 @@
                   <a:srgbClr val="475569"/>
                 </a:solidFill>
               </a:rPr>
-              <a:t> സർക്യൂട്ട്,</a:t>
+              <a:t> കൃഷിചെയ്യുക,</a:t>
             </a:r>
             <a:br>
               <a:rPr lang="en-GB" b="1" dirty="0">
@@ -7470,7 +7470,7 @@
                   <a:srgbClr val="475569"/>
                 </a:solidFill>
               </a:rPr>
-              <a:t>மின்சுற்று</a:t>
+              <a:t>பயிரிடு</a:t>
             </a:r>
             <a:endParaRPr lang="en-IN" b="1" dirty="0">
               <a:solidFill>
@@ -7644,7 +7644,7 @@
                 </a:solidFill>
                 <a:latin typeface="Poppins ExtraBold"/>
               </a:rPr>
-              <a:t>Amplify</a:t>
+              <a:t>harvest</a:t>
             </a:r>
             <a:endParaRPr sz="6600" b="0" i="0" u="none" dirty="0">
               <a:solidFill>
@@ -7685,7 +7685,7 @@
                 </a:solidFill>
                 <a:latin typeface="Poppins"/>
               </a:rPr>
-              <a:t>To increase the strength or volume of an electrical signal.</a:t>
+              <a:t>To gather a ripe crop from the fields.</a:t>
             </a:r>
             <a:endParaRPr sz="2000" b="1" i="0" u="none" dirty="0">
               <a:solidFill>
@@ -7760,7 +7760,7 @@
                 </a:solidFill>
                 <a:latin typeface="Noto Sans SemiBold"/>
               </a:rPr>
-              <a:t>amplify</a:t>
+              <a:t>harvest</a:t>
             </a:r>
             <a:r>
               <a:rPr sz="2000" b="1" dirty="0">
@@ -7792,7 +7792,7 @@
                 </a:solidFill>
                 <a:latin typeface="Noto Sans SemiBold"/>
               </a:rPr>
-              <a:t>amplifies</a:t>
+              <a:t>harvests</a:t>
             </a:r>
             <a:r>
               <a:rPr sz="2000" b="1" dirty="0">
@@ -7824,7 +7824,7 @@
                 </a:solidFill>
                 <a:latin typeface="Noto Sans SemiBold"/>
               </a:rPr>
-              <a:t>amplified</a:t>
+              <a:t>harvested</a:t>
             </a:r>
             <a:endParaRPr sz="2000" b="1" dirty="0">
               <a:solidFill>
@@ -7870,7 +7870,7 @@
                   <a:srgbClr val="475569"/>
                 </a:solidFill>
               </a:rPr>
-              <a:t>बढ़ाना,</a:t>
+              <a:t>फसल काटना,</a:t>
             </a:r>
           </a:p>
           <a:p>
@@ -7881,7 +7881,7 @@
                   <a:srgbClr val="475569"/>
                 </a:solidFill>
               </a:rPr>
-              <a:t> വർദ്ധിപ്പിക്കുക,</a:t>
+              <a:t> വിളവെടുക്കുക,</a:t>
             </a:r>
             <a:br>
               <a:rPr lang="en-GB" b="1" dirty="0">
@@ -7896,7 +7896,7 @@
                   <a:srgbClr val="475569"/>
                 </a:solidFill>
               </a:rPr>
-              <a:t>பெருக்கவும்</a:t>
+              <a:t>அறுவடை செய்</a:t>
             </a:r>
             <a:endParaRPr lang="en-IN" b="1" dirty="0">
               <a:solidFill>
@@ -7986,7 +7986,7 @@
                 </a:solidFill>
                 <a:latin typeface="Poppins ExtraBold"/>
               </a:rPr>
-              <a:t>/ˈæm.plɪ.faɪ/</a:t>
+              <a:t>/ˈhɑːr.vəst/</a:t>
             </a:r>
             <a:endParaRPr sz="1650" u="none" dirty="0">
               <a:solidFill>
@@ -8140,7 +8140,7 @@
                 </a:solidFill>
                 <a:latin typeface="Poppins ExtraBold"/>
               </a:rPr>
-              <a:t>/ˈæm.plɪ.faɪ/</a:t>
+              <a:t>/ˈhɑːr.vəst/</a:t>
             </a:r>
             <a:endParaRPr sz="1650" u="none" dirty="0">
               <a:solidFill>
@@ -8215,7 +8215,7 @@
                 </a:solidFill>
                 <a:latin typeface="Poppins ExtraBold"/>
               </a:rPr>
-              <a:t>Amplify</a:t>
+              <a:t>harvest</a:t>
             </a:r>
             <a:endParaRPr sz="6600" b="0" i="0" u="none" dirty="0">
               <a:solidFill>
@@ -8262,7 +8262,7 @@
                 </a:solidFill>
                 <a:latin typeface="Poppins"/>
               </a:rPr>
-              <a:t>To increase the strength or volume of an electrical signal.</a:t>
+              <a:t>To gather a ripe crop from the fields.</a:t>
             </a:r>
             <a:endParaRPr sz="2000" b="1" i="0" u="none" dirty="0">
               <a:solidFill>
@@ -8337,7 +8337,7 @@
                 </a:solidFill>
                 <a:latin typeface="Noto Sans SemiBold"/>
               </a:rPr>
-              <a:t>amplify</a:t>
+              <a:t>harvest</a:t>
             </a:r>
             <a:r>
               <a:rPr sz="2000" b="1" dirty="0">
@@ -8369,7 +8369,7 @@
                 </a:solidFill>
                 <a:latin typeface="Noto Sans SemiBold"/>
               </a:rPr>
-              <a:t>amplifies</a:t>
+              <a:t>harvests</a:t>
             </a:r>
             <a:r>
               <a:rPr sz="2000" b="1" dirty="0">
@@ -8401,7 +8401,7 @@
                 </a:solidFill>
                 <a:latin typeface="Noto Sans SemiBold"/>
               </a:rPr>
-              <a:t>amplified</a:t>
+              <a:t>harvested</a:t>
             </a:r>
             <a:endParaRPr sz="2000" b="1" dirty="0">
               <a:solidFill>
@@ -8447,7 +8447,7 @@
                 </a:solidFill>
                 <a:latin typeface="Poppins ExtraBold"/>
               </a:rPr>
-              <a:t>The technician amplified the signal to improve the weak radio reception.</a:t>
+              <a:t>The tired farmers harvested all the wheat before the heavy rain started.</a:t>
             </a:r>
             <a:endParaRPr sz="2400" b="0" i="0" u="none" dirty="0">
               <a:solidFill>
@@ -8537,7 +8537,7 @@
                   <a:srgbClr val="475569"/>
                 </a:solidFill>
               </a:rPr>
-              <a:t>बढ़ाना,</a:t>
+              <a:t>फसल काटना,</a:t>
             </a:r>
           </a:p>
           <a:p>
@@ -8548,7 +8548,7 @@
                   <a:srgbClr val="475569"/>
                 </a:solidFill>
               </a:rPr>
-              <a:t> വർദ്ധിപ്പിക്കുക,</a:t>
+              <a:t> വിളവെടുക്കുക,</a:t>
             </a:r>
             <a:br>
               <a:rPr lang="en-GB" b="1" dirty="0">
@@ -8563,7 +8563,7 @@
                   <a:srgbClr val="475569"/>
                 </a:solidFill>
               </a:rPr>
-              <a:t>பெருக்கவும்</a:t>
+              <a:t>அறுவடை செய்</a:t>
             </a:r>
             <a:endParaRPr lang="en-IN" b="1" dirty="0">
               <a:solidFill>
@@ -8716,7 +8716,7 @@
                 </a:solidFill>
                 <a:latin typeface="Poppins ExtraBold"/>
               </a:rPr>
-              <a:t>/ˈæm.plɪ.faɪ/</a:t>
+              <a:t>/ˈhɑːr.vəst/</a:t>
             </a:r>
             <a:endParaRPr sz="1650" u="none" dirty="0">
               <a:solidFill>
@@ -8791,7 +8791,7 @@
                 </a:solidFill>
                 <a:latin typeface="Poppins ExtraBold"/>
               </a:rPr>
-              <a:t>Amplify</a:t>
+              <a:t>harvest</a:t>
             </a:r>
             <a:endParaRPr sz="6600" b="0" i="0" u="none" dirty="0">
               <a:solidFill>
@@ -8838,7 +8838,7 @@
                 </a:solidFill>
                 <a:latin typeface="Poppins"/>
               </a:rPr>
-              <a:t>To increase the strength or volume of an electrical signal.</a:t>
+              <a:t>To gather a ripe crop from the fields.</a:t>
             </a:r>
             <a:endParaRPr sz="2000" b="1" i="0" u="none" dirty="0">
               <a:solidFill>
@@ -8913,7 +8913,7 @@
                 </a:solidFill>
                 <a:latin typeface="Noto Sans SemiBold"/>
               </a:rPr>
-              <a:t>amplify</a:t>
+              <a:t>harvest</a:t>
             </a:r>
             <a:r>
               <a:rPr sz="2000" b="1" dirty="0">
@@ -8945,7 +8945,7 @@
                 </a:solidFill>
                 <a:latin typeface="Noto Sans SemiBold"/>
               </a:rPr>
-              <a:t>amplifies</a:t>
+              <a:t>harvests</a:t>
             </a:r>
             <a:r>
               <a:rPr sz="2000" b="1" dirty="0">
@@ -8977,7 +8977,7 @@
                 </a:solidFill>
                 <a:latin typeface="Noto Sans SemiBold"/>
               </a:rPr>
-              <a:t>amplified</a:t>
+              <a:t>harvested</a:t>
             </a:r>
             <a:endParaRPr sz="2000" b="1" dirty="0">
               <a:solidFill>
@@ -9023,7 +9023,7 @@
                 </a:solidFill>
                 <a:latin typeface="Poppins ExtraBold"/>
               </a:rPr>
-              <a:t>The technician amplified the signal to improve the weak radio reception.</a:t>
+              <a:t>The tired farmers harvested all the wheat before the heavy rain started.</a:t>
             </a:r>
             <a:endParaRPr sz="2400" b="0" i="0" u="none" dirty="0">
               <a:solidFill>
@@ -9068,7 +9068,7 @@
                   <a:srgbClr val="2A3644"/>
                 </a:solidFill>
               </a:rPr>
-              <a:t>This small device amplifies audio signals without causing any sound distortion.</a:t>
+              <a:t>Workers harvest fresh apples from the orchard early in the morning.</a:t>
             </a:r>
             <a:endParaRPr lang="en-IN" sz="2400" b="1" dirty="0">
               <a:solidFill>
@@ -9157,7 +9157,7 @@
                   <a:srgbClr val="475569"/>
                 </a:solidFill>
               </a:rPr>
-              <a:t>बढ़ाना,</a:t>
+              <a:t>फसल काटना,</a:t>
             </a:r>
           </a:p>
           <a:p>
@@ -9168,7 +9168,7 @@
                   <a:srgbClr val="475569"/>
                 </a:solidFill>
               </a:rPr>
-              <a:t> വർദ്ധിപ്പിക്കുക,</a:t>
+              <a:t> വിളവെടുക്കുക,</a:t>
             </a:r>
             <a:br>
               <a:rPr lang="en-GB" b="1" dirty="0">
@@ -9183,7 +9183,7 @@
                   <a:srgbClr val="475569"/>
                 </a:solidFill>
               </a:rPr>
-              <a:t>பெருக்கவும்</a:t>
+              <a:t>அறுவடை செய்</a:t>
             </a:r>
             <a:endParaRPr lang="en-IN" b="1" dirty="0">
               <a:solidFill>
@@ -9336,7 +9336,7 @@
                 </a:solidFill>
                 <a:latin typeface="Poppins ExtraBold"/>
               </a:rPr>
-              <a:t>/ˈæm.plɪ.faɪ/</a:t>
+              <a:t>/ˈhɑːr.vəst/</a:t>
             </a:r>
             <a:endParaRPr sz="1650" u="none" dirty="0">
               <a:solidFill>
@@ -9411,7 +9411,7 @@
                 </a:solidFill>
                 <a:latin typeface="Poppins ExtraBold"/>
               </a:rPr>
-              <a:t>Amplify</a:t>
+              <a:t>harvest</a:t>
             </a:r>
             <a:endParaRPr sz="6600" b="0" i="0" u="none" dirty="0">
               <a:solidFill>
@@ -9458,7 +9458,7 @@
                 </a:solidFill>
                 <a:latin typeface="Poppins"/>
               </a:rPr>
-              <a:t>To increase the strength or volume of an electrical signal.</a:t>
+              <a:t>To gather a ripe crop from the fields.</a:t>
             </a:r>
             <a:endParaRPr sz="2000" b="1" i="0" u="none" dirty="0">
               <a:solidFill>
@@ -9533,7 +9533,7 @@
                 </a:solidFill>
                 <a:latin typeface="Noto Sans SemiBold"/>
               </a:rPr>
-              <a:t>amplify</a:t>
+              <a:t>harvest</a:t>
             </a:r>
             <a:r>
               <a:rPr sz="2000" b="1" dirty="0">
@@ -9565,7 +9565,7 @@
                 </a:solidFill>
                 <a:latin typeface="Noto Sans SemiBold"/>
               </a:rPr>
-              <a:t>amplifies</a:t>
+              <a:t>harvests</a:t>
             </a:r>
             <a:r>
               <a:rPr sz="2000" b="1" dirty="0">
@@ -9597,7 +9597,7 @@
                 </a:solidFill>
                 <a:latin typeface="Noto Sans SemiBold"/>
               </a:rPr>
-              <a:t>amplified</a:t>
+              <a:t>harvested</a:t>
             </a:r>
             <a:endParaRPr sz="2000" b="1" dirty="0">
               <a:solidFill>
@@ -9643,7 +9643,7 @@
                 </a:solidFill>
                 <a:latin typeface="Poppins ExtraBold"/>
               </a:rPr>
-              <a:t>The technician amplified the signal to improve the weak radio reception.</a:t>
+              <a:t>The tired farmers harvested all the wheat before the heavy rain started.</a:t>
             </a:r>
             <a:endParaRPr sz="2400" b="0" i="0" u="none" dirty="0">
               <a:solidFill>
@@ -9688,7 +9688,7 @@
                   <a:srgbClr val="2A3644"/>
                 </a:solidFill>
               </a:rPr>
-              <a:t>This small device amplifies audio signals without causing any sound distortion.</a:t>
+              <a:t>Workers harvest fresh apples from the orchard early in the morning.</a:t>
             </a:r>
             <a:endParaRPr lang="en-IN" sz="2400" b="1" dirty="0">
               <a:solidFill>
@@ -9732,7 +9732,7 @@
                   <a:srgbClr val="2A3644"/>
                 </a:solidFill>
               </a:rPr>
-              <a:t>The new speaker system will amplify sound clearly across the large room.</a:t>
+              <a:t>They will harvest the golden grain when it becomes completely ripe tomorrow.</a:t>
             </a:r>
             <a:endParaRPr lang="en-IN" sz="2400" b="1" dirty="0">
               <a:solidFill>
@@ -9821,7 +9821,7 @@
                   <a:srgbClr val="475569"/>
                 </a:solidFill>
               </a:rPr>
-              <a:t>बढ़ाना,</a:t>
+              <a:t>फसल काटना,</a:t>
             </a:r>
           </a:p>
           <a:p>
@@ -9832,7 +9832,7 @@
                   <a:srgbClr val="475569"/>
                 </a:solidFill>
               </a:rPr>
-              <a:t> വർദ്ധിപ്പിക്കുക,</a:t>
+              <a:t> വിളവെടുക്കുക,</a:t>
             </a:r>
             <a:br>
               <a:rPr lang="en-GB" b="1" dirty="0">
@@ -9847,7 +9847,7 @@
                   <a:srgbClr val="475569"/>
                 </a:solidFill>
               </a:rPr>
-              <a:t>பெருக்கவும்</a:t>
+              <a:t>அறுவடை செய்</a:t>
             </a:r>
             <a:endParaRPr lang="en-IN" b="1" dirty="0">
               <a:solidFill>
@@ -10016,7 +10016,7 @@
                 </a:solidFill>
                 <a:latin typeface="Poppins ExtraBold"/>
               </a:rPr>
-              <a:t>Conductor</a:t>
+              <a:t>irrigation</a:t>
             </a:r>
             <a:endParaRPr sz="6600" b="0" i="0" u="none" dirty="0">
               <a:solidFill>
@@ -10057,7 +10057,7 @@
                 </a:solidFill>
                 <a:latin typeface="Poppins"/>
               </a:rPr>
-              <a:t>A material or device that allows electricity to flow through easily.</a:t>
+              <a:t>The supply of water to land or crops to help growth.</a:t>
             </a:r>
             <a:endParaRPr sz="2000" b="1" i="0" u="none" dirty="0">
               <a:solidFill>
@@ -10242,7 +10242,7 @@
                   <a:srgbClr val="475569"/>
                 </a:solidFill>
               </a:rPr>
-              <a:t>चालक,</a:t>
+              <a:t>सिंचाई,</a:t>
             </a:r>
           </a:p>
           <a:p>
@@ -10253,7 +10253,7 @@
                   <a:srgbClr val="475569"/>
                 </a:solidFill>
               </a:rPr>
-              <a:t> ചാലകം,</a:t>
+              <a:t> ജലസേചനം,</a:t>
             </a:r>
             <a:br>
               <a:rPr lang="en-GB" b="1" dirty="0">
@@ -10268,7 +10268,7 @@
                   <a:srgbClr val="475569"/>
                 </a:solidFill>
               </a:rPr>
-              <a:t>கடத்தி</a:t>
+              <a:t>பாசனம்</a:t>
             </a:r>
             <a:endParaRPr lang="en-IN" b="1" dirty="0">
               <a:solidFill>
@@ -10358,7 +10358,7 @@
                 </a:solidFill>
                 <a:latin typeface="Poppins ExtraBold"/>
               </a:rPr>
-              <a:t>/kənˈdʌk.tər/</a:t>
+              <a:t>/ˌɪr.əˈɡeɪ.ʃən/</a:t>
             </a:r>
             <a:endParaRPr sz="1650" u="none" dirty="0">
               <a:solidFill>

</xml_diff>

<commit_message>
Audio, slide timing and duration phase completed
</commit_message>
<xml_diff>
--- a/output/test_builder.pptx
+++ b/output/test_builder.pptx
@@ -313,7 +313,7 @@
           <a:p>
             <a:fld id="{5BCAD085-E8A6-8845-BD4E-CB4CCA059FC4}" type="datetimeFigureOut">
               <a:rPr lang="en-US" smtClean="0"/>
-              <a:t>8/1/2026</a:t>
+              <a:t>8/3/2026</a:t>
             </a:fld>
             <a:endParaRPr lang="en-US"/>
           </a:p>
@@ -481,7 +481,7 @@
           <a:p>
             <a:fld id="{5BCAD085-E8A6-8845-BD4E-CB4CCA059FC4}" type="datetimeFigureOut">
               <a:rPr lang="en-US" smtClean="0"/>
-              <a:t>8/1/2026</a:t>
+              <a:t>8/3/2026</a:t>
             </a:fld>
             <a:endParaRPr lang="en-US"/>
           </a:p>
@@ -659,7 +659,7 @@
           <a:p>
             <a:fld id="{5BCAD085-E8A6-8845-BD4E-CB4CCA059FC4}" type="datetimeFigureOut">
               <a:rPr lang="en-US" smtClean="0"/>
-              <a:t>8/1/2026</a:t>
+              <a:t>8/3/2026</a:t>
             </a:fld>
             <a:endParaRPr lang="en-US"/>
           </a:p>
@@ -827,7 +827,7 @@
           <a:p>
             <a:fld id="{5BCAD085-E8A6-8845-BD4E-CB4CCA059FC4}" type="datetimeFigureOut">
               <a:rPr lang="en-US" smtClean="0"/>
-              <a:t>8/1/2026</a:t>
+              <a:t>8/3/2026</a:t>
             </a:fld>
             <a:endParaRPr lang="en-US"/>
           </a:p>
@@ -1072,7 +1072,7 @@
           <a:p>
             <a:fld id="{5BCAD085-E8A6-8845-BD4E-CB4CCA059FC4}" type="datetimeFigureOut">
               <a:rPr lang="en-US" smtClean="0"/>
-              <a:t>8/1/2026</a:t>
+              <a:t>8/3/2026</a:t>
             </a:fld>
             <a:endParaRPr lang="en-US"/>
           </a:p>
@@ -1357,7 +1357,7 @@
           <a:p>
             <a:fld id="{5BCAD085-E8A6-8845-BD4E-CB4CCA059FC4}" type="datetimeFigureOut">
               <a:rPr lang="en-US" smtClean="0"/>
-              <a:t>8/1/2026</a:t>
+              <a:t>8/3/2026</a:t>
             </a:fld>
             <a:endParaRPr lang="en-US"/>
           </a:p>
@@ -1776,7 +1776,7 @@
           <a:p>
             <a:fld id="{5BCAD085-E8A6-8845-BD4E-CB4CCA059FC4}" type="datetimeFigureOut">
               <a:rPr lang="en-US" smtClean="0"/>
-              <a:t>8/1/2026</a:t>
+              <a:t>8/3/2026</a:t>
             </a:fld>
             <a:endParaRPr lang="en-US"/>
           </a:p>
@@ -1893,7 +1893,7 @@
           <a:p>
             <a:fld id="{5BCAD085-E8A6-8845-BD4E-CB4CCA059FC4}" type="datetimeFigureOut">
               <a:rPr lang="en-US" smtClean="0"/>
-              <a:t>8/1/2026</a:t>
+              <a:t>8/3/2026</a:t>
             </a:fld>
             <a:endParaRPr lang="en-US"/>
           </a:p>
@@ -1988,7 +1988,7 @@
           <a:p>
             <a:fld id="{5BCAD085-E8A6-8845-BD4E-CB4CCA059FC4}" type="datetimeFigureOut">
               <a:rPr lang="en-US" smtClean="0"/>
-              <a:t>8/1/2026</a:t>
+              <a:t>8/3/2026</a:t>
             </a:fld>
             <a:endParaRPr lang="en-US"/>
           </a:p>
@@ -2263,7 +2263,7 @@
           <a:p>
             <a:fld id="{5BCAD085-E8A6-8845-BD4E-CB4CCA059FC4}" type="datetimeFigureOut">
               <a:rPr lang="en-US" smtClean="0"/>
-              <a:t>8/1/2026</a:t>
+              <a:t>8/3/2026</a:t>
             </a:fld>
             <a:endParaRPr lang="en-US"/>
           </a:p>
@@ -2515,7 +2515,7 @@
           <a:p>
             <a:fld id="{5BCAD085-E8A6-8845-BD4E-CB4CCA059FC4}" type="datetimeFigureOut">
               <a:rPr lang="en-US" smtClean="0"/>
-              <a:t>8/1/2026</a:t>
+              <a:t>8/3/2026</a:t>
             </a:fld>
             <a:endParaRPr lang="en-US"/>
           </a:p>
@@ -2726,7 +2726,7 @@
           <a:p>
             <a:fld id="{5BCAD085-E8A6-8845-BD4E-CB4CCA059FC4}" type="datetimeFigureOut">
               <a:rPr lang="en-US" smtClean="0"/>
-              <a:t>8/1/2026</a:t>
+              <a:t>8/3/2026</a:t>
             </a:fld>
             <a:endParaRPr lang="en-US"/>
           </a:p>
@@ -3363,15 +3363,6 @@
               <a:t>cultivate</a:t>
             </a:r>
             <a:r>
-              <a:rPr sz="2000" b="1" dirty="0">
-                <a:solidFill>
-                  <a:srgbClr val="475569"/>
-                </a:solidFill>
-                <a:latin typeface="Noto Sans SemiBold"/>
-              </a:rPr>
-              <a:t>,</a:t>
-            </a:r>
-            <a:r>
               <a:rPr sz="1600" b="1" dirty="0"/>
               <a:t>
 </a:t>
@@ -3393,15 +3384,6 @@
                 <a:latin typeface="Noto Sans SemiBold"/>
               </a:rPr>
               <a:t>cultivates</a:t>
-            </a:r>
-            <a:r>
-              <a:rPr sz="2000" b="1" dirty="0">
-                <a:solidFill>
-                  <a:srgbClr val="475569"/>
-                </a:solidFill>
-                <a:latin typeface="Noto Sans SemiBold"/>
-              </a:rPr>
-              <a:t>,</a:t>
             </a:r>
             <a:r>
               <a:rPr sz="1600" b="1" dirty="0"/>
@@ -3940,15 +3922,6 @@
               <a:t/>
             </a:r>
             <a:r>
-              <a:rPr sz="2000" b="1" dirty="0">
-                <a:solidFill>
-                  <a:srgbClr val="475569"/>
-                </a:solidFill>
-                <a:latin typeface="Noto Sans SemiBold"/>
-              </a:rPr>
-              <a:t>,</a:t>
-            </a:r>
-            <a:r>
               <a:rPr sz="1600" b="1" dirty="0"/>
               <a:t>
 </a:t>
@@ -3970,15 +3943,6 @@
                 <a:latin typeface="Noto Sans SemiBold"/>
               </a:rPr>
               <a:t/>
-            </a:r>
-            <a:r>
-              <a:rPr sz="2000" b="1" dirty="0">
-                <a:solidFill>
-                  <a:srgbClr val="475569"/>
-                </a:solidFill>
-                <a:latin typeface="Noto Sans SemiBold"/>
-              </a:rPr>
-              <a:t>,</a:t>
             </a:r>
             <a:r>
               <a:rPr sz="1600" b="1" dirty="0"/>
@@ -4516,15 +4480,6 @@
               <a:t/>
             </a:r>
             <a:r>
-              <a:rPr sz="2000" b="1" dirty="0">
-                <a:solidFill>
-                  <a:srgbClr val="475569"/>
-                </a:solidFill>
-                <a:latin typeface="Noto Sans SemiBold"/>
-              </a:rPr>
-              <a:t>,</a:t>
-            </a:r>
-            <a:r>
               <a:rPr sz="1600" b="1" dirty="0"/>
               <a:t>
 </a:t>
@@ -4546,15 +4501,6 @@
                 <a:latin typeface="Noto Sans SemiBold"/>
               </a:rPr>
               <a:t/>
-            </a:r>
-            <a:r>
-              <a:rPr sz="2000" b="1" dirty="0">
-                <a:solidFill>
-                  <a:srgbClr val="475569"/>
-                </a:solidFill>
-                <a:latin typeface="Noto Sans SemiBold"/>
-              </a:rPr>
-              <a:t>,</a:t>
             </a:r>
             <a:r>
               <a:rPr sz="1600" b="1" dirty="0"/>
@@ -4667,6 +4613,8 @@
                 <a:solidFill>
                   <a:srgbClr val="2A3644"/>
                 </a:solidFill>
+                <a:latin typeface="Poppins ExtraBold" panose="00000900000000000000" pitchFamily="2" charset="0"/>
+                <a:cs typeface="Poppins ExtraBold" panose="00000900000000000000" pitchFamily="2" charset="0"/>
               </a:rPr>
               <a:t>Modern irrigation provides enough water for crops during dry weather conditions.</a:t>
             </a:r>
@@ -4674,6 +4622,8 @@
               <a:solidFill>
                 <a:srgbClr val="2A3644"/>
               </a:solidFill>
+              <a:latin typeface="Poppins ExtraBold" panose="00000900000000000000" pitchFamily="2" charset="0"/>
+              <a:cs typeface="Poppins ExtraBold" panose="00000900000000000000" pitchFamily="2" charset="0"/>
             </a:endParaRPr>
           </a:p>
         </p:txBody>
@@ -5136,15 +5086,6 @@
               <a:t/>
             </a:r>
             <a:r>
-              <a:rPr sz="2000" b="1" dirty="0">
-                <a:solidFill>
-                  <a:srgbClr val="475569"/>
-                </a:solidFill>
-                <a:latin typeface="Noto Sans SemiBold"/>
-              </a:rPr>
-              <a:t>,</a:t>
-            </a:r>
-            <a:r>
               <a:rPr sz="1600" b="1" dirty="0"/>
               <a:t>
 </a:t>
@@ -5166,15 +5107,6 @@
                 <a:latin typeface="Noto Sans SemiBold"/>
               </a:rPr>
               <a:t/>
-            </a:r>
-            <a:r>
-              <a:rPr sz="2000" b="1" dirty="0">
-                <a:solidFill>
-                  <a:srgbClr val="475569"/>
-                </a:solidFill>
-                <a:latin typeface="Noto Sans SemiBold"/>
-              </a:rPr>
-              <a:t>,</a:t>
             </a:r>
             <a:r>
               <a:rPr sz="1600" b="1" dirty="0"/>
@@ -5287,6 +5219,8 @@
                 <a:solidFill>
                   <a:srgbClr val="2A3644"/>
                 </a:solidFill>
+                <a:latin typeface="Poppins ExtraBold" panose="00000900000000000000" pitchFamily="2" charset="0"/>
+                <a:cs typeface="Poppins ExtraBold" panose="00000900000000000000" pitchFamily="2" charset="0"/>
               </a:rPr>
               <a:t>Modern irrigation provides enough water for crops during dry weather conditions.</a:t>
             </a:r>
@@ -5294,6 +5228,8 @@
               <a:solidFill>
                 <a:srgbClr val="2A3644"/>
               </a:solidFill>
+              <a:latin typeface="Poppins ExtraBold" panose="00000900000000000000" pitchFamily="2" charset="0"/>
+              <a:cs typeface="Poppins ExtraBold" panose="00000900000000000000" pitchFamily="2" charset="0"/>
             </a:endParaRPr>
           </a:p>
         </p:txBody>
@@ -5313,7 +5249,7 @@
         <p:spPr>
           <a:xfrm>
             <a:off x="3794638" y="5554756"/>
-            <a:ext cx="6593757" cy="461665"/>
+            <a:ext cx="7468214" cy="461665"/>
           </a:xfrm>
           <a:prstGeom prst="rect">
             <a:avLst/>
@@ -5331,6 +5267,8 @@
                 <a:solidFill>
                   <a:srgbClr val="2A3644"/>
                 </a:solidFill>
+                <a:latin typeface="Poppins ExtraBold" panose="00000900000000000000" pitchFamily="2" charset="0"/>
+                <a:cs typeface="Poppins ExtraBold" panose="00000900000000000000" pitchFamily="2" charset="0"/>
               </a:rPr>
               <a:t>A new irrigation project will help farmers grow crops during dry summer.</a:t>
             </a:r>
@@ -5338,6 +5276,8 @@
               <a:solidFill>
                 <a:srgbClr val="2A3644"/>
               </a:solidFill>
+              <a:latin typeface="Poppins ExtraBold" panose="00000900000000000000" pitchFamily="2" charset="0"/>
+              <a:cs typeface="Poppins ExtraBold" panose="00000900000000000000" pitchFamily="2" charset="0"/>
             </a:endParaRPr>
           </a:p>
         </p:txBody>
@@ -5851,15 +5791,6 @@
               <a:t>cultivate</a:t>
             </a:r>
             <a:r>
-              <a:rPr sz="2000" b="1" dirty="0">
-                <a:solidFill>
-                  <a:srgbClr val="475569"/>
-                </a:solidFill>
-                <a:latin typeface="Noto Sans SemiBold"/>
-              </a:rPr>
-              <a:t>,</a:t>
-            </a:r>
-            <a:r>
               <a:rPr sz="1600" b="1" dirty="0"/>
               <a:t>
 </a:t>
@@ -5881,15 +5812,6 @@
                 <a:latin typeface="Noto Sans SemiBold"/>
               </a:rPr>
               <a:t>cultivates</a:t>
-            </a:r>
-            <a:r>
-              <a:rPr sz="2000" b="1" dirty="0">
-                <a:solidFill>
-                  <a:srgbClr val="475569"/>
-                </a:solidFill>
-                <a:latin typeface="Noto Sans SemiBold"/>
-              </a:rPr>
-              <a:t>,</a:t>
             </a:r>
             <a:r>
               <a:rPr sz="1600" b="1" dirty="0"/>
@@ -6483,15 +6405,6 @@
               <a:t>cultivate</a:t>
             </a:r>
             <a:r>
-              <a:rPr sz="2000" b="1" dirty="0">
-                <a:solidFill>
-                  <a:srgbClr val="475569"/>
-                </a:solidFill>
-                <a:latin typeface="Noto Sans SemiBold"/>
-              </a:rPr>
-              <a:t>,</a:t>
-            </a:r>
-            <a:r>
               <a:rPr sz="1600" b="1" dirty="0"/>
               <a:t>
 </a:t>
@@ -6513,15 +6426,6 @@
                 <a:latin typeface="Noto Sans SemiBold"/>
               </a:rPr>
               <a:t>cultivates</a:t>
-            </a:r>
-            <a:r>
-              <a:rPr sz="2000" b="1" dirty="0">
-                <a:solidFill>
-                  <a:srgbClr val="475569"/>
-                </a:solidFill>
-                <a:latin typeface="Noto Sans SemiBold"/>
-              </a:rPr>
-              <a:t>,</a:t>
             </a:r>
             <a:r>
               <a:rPr sz="1600" b="1" dirty="0"/>
@@ -6634,6 +6538,8 @@
                 <a:solidFill>
                   <a:srgbClr val="2A3644"/>
                 </a:solidFill>
+                <a:latin typeface="Poppins ExtraBold" panose="00000900000000000000" pitchFamily="2" charset="0"/>
+                <a:cs typeface="Poppins ExtraBold" panose="00000900000000000000" pitchFamily="2" charset="0"/>
               </a:rPr>
               <a:t>Farmers cultivate the fertile soil every spring to prepare for planting crops.</a:t>
             </a:r>
@@ -6641,6 +6547,8 @@
               <a:solidFill>
                 <a:srgbClr val="2A3644"/>
               </a:solidFill>
+              <a:latin typeface="Poppins ExtraBold" panose="00000900000000000000" pitchFamily="2" charset="0"/>
+              <a:cs typeface="Poppins ExtraBold" panose="00000900000000000000" pitchFamily="2" charset="0"/>
             </a:endParaRPr>
           </a:p>
         </p:txBody>
@@ -7159,15 +7067,6 @@
               <a:t>cultivate</a:t>
             </a:r>
             <a:r>
-              <a:rPr sz="2000" b="1" dirty="0">
-                <a:solidFill>
-                  <a:srgbClr val="475569"/>
-                </a:solidFill>
-                <a:latin typeface="Noto Sans SemiBold"/>
-              </a:rPr>
-              <a:t>,</a:t>
-            </a:r>
-            <a:r>
               <a:rPr sz="1600" b="1" dirty="0"/>
               <a:t>
 </a:t>
@@ -7189,15 +7088,6 @@
                 <a:latin typeface="Noto Sans SemiBold"/>
               </a:rPr>
               <a:t>cultivates</a:t>
-            </a:r>
-            <a:r>
-              <a:rPr sz="2000" b="1" dirty="0">
-                <a:solidFill>
-                  <a:srgbClr val="475569"/>
-                </a:solidFill>
-                <a:latin typeface="Noto Sans SemiBold"/>
-              </a:rPr>
-              <a:t>,</a:t>
             </a:r>
             <a:r>
               <a:rPr sz="1600" b="1" dirty="0"/>
@@ -7310,6 +7200,8 @@
                 <a:solidFill>
                   <a:srgbClr val="2A3644"/>
                 </a:solidFill>
+                <a:latin typeface="Poppins ExtraBold" panose="00000900000000000000" pitchFamily="2" charset="0"/>
+                <a:cs typeface="Poppins ExtraBold" panose="00000900000000000000" pitchFamily="2" charset="0"/>
               </a:rPr>
               <a:t>Farmers cultivate the fertile soil every spring to prepare for planting crops.</a:t>
             </a:r>
@@ -7317,6 +7209,8 @@
               <a:solidFill>
                 <a:srgbClr val="2A3644"/>
               </a:solidFill>
+              <a:latin typeface="Poppins ExtraBold" panose="00000900000000000000" pitchFamily="2" charset="0"/>
+              <a:cs typeface="Poppins ExtraBold" panose="00000900000000000000" pitchFamily="2" charset="0"/>
             </a:endParaRPr>
           </a:p>
         </p:txBody>
@@ -7336,7 +7230,7 @@
         <p:spPr>
           <a:xfrm>
             <a:off x="3794638" y="5554756"/>
-            <a:ext cx="6593757" cy="461665"/>
+            <a:ext cx="7468214" cy="461665"/>
           </a:xfrm>
           <a:prstGeom prst="rect">
             <a:avLst/>
@@ -7354,6 +7248,8 @@
                 <a:solidFill>
                   <a:srgbClr val="2A3644"/>
                 </a:solidFill>
+                <a:latin typeface="Poppins ExtraBold" panose="00000900000000000000" pitchFamily="2" charset="0"/>
+                <a:cs typeface="Poppins ExtraBold" panose="00000900000000000000" pitchFamily="2" charset="0"/>
               </a:rPr>
               <a:t>Next season, our community will cultivate a large field of sweet corn.</a:t>
             </a:r>
@@ -7361,6 +7257,8 @@
               <a:solidFill>
                 <a:srgbClr val="2A3644"/>
               </a:solidFill>
+              <a:latin typeface="Poppins ExtraBold" panose="00000900000000000000" pitchFamily="2" charset="0"/>
+              <a:cs typeface="Poppins ExtraBold" panose="00000900000000000000" pitchFamily="2" charset="0"/>
             </a:endParaRPr>
           </a:p>
         </p:txBody>
@@ -7763,15 +7661,6 @@
               <a:t>harvest</a:t>
             </a:r>
             <a:r>
-              <a:rPr sz="2000" b="1" dirty="0">
-                <a:solidFill>
-                  <a:srgbClr val="475569"/>
-                </a:solidFill>
-                <a:latin typeface="Noto Sans SemiBold"/>
-              </a:rPr>
-              <a:t>,</a:t>
-            </a:r>
-            <a:r>
               <a:rPr sz="1600" b="1" dirty="0"/>
               <a:t>
 </a:t>
@@ -7793,15 +7682,6 @@
                 <a:latin typeface="Noto Sans SemiBold"/>
               </a:rPr>
               <a:t>harvests</a:t>
-            </a:r>
-            <a:r>
-              <a:rPr sz="2000" b="1" dirty="0">
-                <a:solidFill>
-                  <a:srgbClr val="475569"/>
-                </a:solidFill>
-                <a:latin typeface="Noto Sans SemiBold"/>
-              </a:rPr>
-              <a:t>,</a:t>
             </a:r>
             <a:r>
               <a:rPr sz="1600" b="1" dirty="0"/>
@@ -8340,15 +8220,6 @@
               <a:t>harvest</a:t>
             </a:r>
             <a:r>
-              <a:rPr sz="2000" b="1" dirty="0">
-                <a:solidFill>
-                  <a:srgbClr val="475569"/>
-                </a:solidFill>
-                <a:latin typeface="Noto Sans SemiBold"/>
-              </a:rPr>
-              <a:t>,</a:t>
-            </a:r>
-            <a:r>
               <a:rPr sz="1600" b="1" dirty="0"/>
               <a:t>
 </a:t>
@@ -8370,15 +8241,6 @@
                 <a:latin typeface="Noto Sans SemiBold"/>
               </a:rPr>
               <a:t>harvests</a:t>
-            </a:r>
-            <a:r>
-              <a:rPr sz="2000" b="1" dirty="0">
-                <a:solidFill>
-                  <a:srgbClr val="475569"/>
-                </a:solidFill>
-                <a:latin typeface="Noto Sans SemiBold"/>
-              </a:rPr>
-              <a:t>,</a:t>
             </a:r>
             <a:r>
               <a:rPr sz="1600" b="1" dirty="0"/>
@@ -8916,15 +8778,6 @@
               <a:t>harvest</a:t>
             </a:r>
             <a:r>
-              <a:rPr sz="2000" b="1" dirty="0">
-                <a:solidFill>
-                  <a:srgbClr val="475569"/>
-                </a:solidFill>
-                <a:latin typeface="Noto Sans SemiBold"/>
-              </a:rPr>
-              <a:t>,</a:t>
-            </a:r>
-            <a:r>
               <a:rPr sz="1600" b="1" dirty="0"/>
               <a:t>
 </a:t>
@@ -8946,15 +8799,6 @@
                 <a:latin typeface="Noto Sans SemiBold"/>
               </a:rPr>
               <a:t>harvests</a:t>
-            </a:r>
-            <a:r>
-              <a:rPr sz="2000" b="1" dirty="0">
-                <a:solidFill>
-                  <a:srgbClr val="475569"/>
-                </a:solidFill>
-                <a:latin typeface="Noto Sans SemiBold"/>
-              </a:rPr>
-              <a:t>,</a:t>
             </a:r>
             <a:r>
               <a:rPr sz="1600" b="1" dirty="0"/>
@@ -9067,6 +8911,8 @@
                 <a:solidFill>
                   <a:srgbClr val="2A3644"/>
                 </a:solidFill>
+                <a:latin typeface="Poppins ExtraBold" panose="00000900000000000000" pitchFamily="2" charset="0"/>
+                <a:cs typeface="Poppins ExtraBold" panose="00000900000000000000" pitchFamily="2" charset="0"/>
               </a:rPr>
               <a:t>Workers harvest fresh apples from the orchard early in the morning.</a:t>
             </a:r>
@@ -9074,6 +8920,8 @@
               <a:solidFill>
                 <a:srgbClr val="2A3644"/>
               </a:solidFill>
+              <a:latin typeface="Poppins ExtraBold" panose="00000900000000000000" pitchFamily="2" charset="0"/>
+              <a:cs typeface="Poppins ExtraBold" panose="00000900000000000000" pitchFamily="2" charset="0"/>
             </a:endParaRPr>
           </a:p>
         </p:txBody>
@@ -9536,15 +9384,6 @@
               <a:t>harvest</a:t>
             </a:r>
             <a:r>
-              <a:rPr sz="2000" b="1" dirty="0">
-                <a:solidFill>
-                  <a:srgbClr val="475569"/>
-                </a:solidFill>
-                <a:latin typeface="Noto Sans SemiBold"/>
-              </a:rPr>
-              <a:t>,</a:t>
-            </a:r>
-            <a:r>
               <a:rPr sz="1600" b="1" dirty="0"/>
               <a:t>
 </a:t>
@@ -9566,15 +9405,6 @@
                 <a:latin typeface="Noto Sans SemiBold"/>
               </a:rPr>
               <a:t>harvests</a:t>
-            </a:r>
-            <a:r>
-              <a:rPr sz="2000" b="1" dirty="0">
-                <a:solidFill>
-                  <a:srgbClr val="475569"/>
-                </a:solidFill>
-                <a:latin typeface="Noto Sans SemiBold"/>
-              </a:rPr>
-              <a:t>,</a:t>
             </a:r>
             <a:r>
               <a:rPr sz="1600" b="1" dirty="0"/>
@@ -9687,6 +9517,8 @@
                 <a:solidFill>
                   <a:srgbClr val="2A3644"/>
                 </a:solidFill>
+                <a:latin typeface="Poppins ExtraBold" panose="00000900000000000000" pitchFamily="2" charset="0"/>
+                <a:cs typeface="Poppins ExtraBold" panose="00000900000000000000" pitchFamily="2" charset="0"/>
               </a:rPr>
               <a:t>Workers harvest fresh apples from the orchard early in the morning.</a:t>
             </a:r>
@@ -9694,6 +9526,8 @@
               <a:solidFill>
                 <a:srgbClr val="2A3644"/>
               </a:solidFill>
+              <a:latin typeface="Poppins ExtraBold" panose="00000900000000000000" pitchFamily="2" charset="0"/>
+              <a:cs typeface="Poppins ExtraBold" panose="00000900000000000000" pitchFamily="2" charset="0"/>
             </a:endParaRPr>
           </a:p>
         </p:txBody>
@@ -9713,7 +9547,7 @@
         <p:spPr>
           <a:xfrm>
             <a:off x="3794638" y="5554756"/>
-            <a:ext cx="6593757" cy="461665"/>
+            <a:ext cx="7468214" cy="461665"/>
           </a:xfrm>
           <a:prstGeom prst="rect">
             <a:avLst/>
@@ -9731,6 +9565,8 @@
                 <a:solidFill>
                   <a:srgbClr val="2A3644"/>
                 </a:solidFill>
+                <a:latin typeface="Poppins ExtraBold" panose="00000900000000000000" pitchFamily="2" charset="0"/>
+                <a:cs typeface="Poppins ExtraBold" panose="00000900000000000000" pitchFamily="2" charset="0"/>
               </a:rPr>
               <a:t>They will harvest the golden grain when it becomes completely ripe tomorrow.</a:t>
             </a:r>
@@ -9738,6 +9574,8 @@
               <a:solidFill>
                 <a:srgbClr val="2A3644"/>
               </a:solidFill>
+              <a:latin typeface="Poppins ExtraBold" panose="00000900000000000000" pitchFamily="2" charset="0"/>
+              <a:cs typeface="Poppins ExtraBold" panose="00000900000000000000" pitchFamily="2" charset="0"/>
             </a:endParaRPr>
           </a:p>
         </p:txBody>
@@ -10135,15 +9973,6 @@
               <a:t/>
             </a:r>
             <a:r>
-              <a:rPr sz="2000" b="1" dirty="0">
-                <a:solidFill>
-                  <a:srgbClr val="475569"/>
-                </a:solidFill>
-                <a:latin typeface="Noto Sans SemiBold"/>
-              </a:rPr>
-              <a:t>,</a:t>
-            </a:r>
-            <a:r>
               <a:rPr sz="1600" b="1" dirty="0"/>
               <a:t>
 </a:t>
@@ -10165,15 +9994,6 @@
                 <a:latin typeface="Noto Sans SemiBold"/>
               </a:rPr>
               <a:t/>
-            </a:r>
-            <a:r>
-              <a:rPr sz="2000" b="1" dirty="0">
-                <a:solidFill>
-                  <a:srgbClr val="475569"/>
-                </a:solidFill>
-                <a:latin typeface="Noto Sans SemiBold"/>
-              </a:rPr>
-              <a:t>,</a:t>
             </a:r>
             <a:r>
               <a:rPr sz="1600" b="1" dirty="0"/>

</xml_diff>

<commit_message>
feat: embed audio into generated presentations using PowerPoint COM
</commit_message>
<xml_diff>
--- a/output/test_builder.pptx
+++ b/output/test_builder.pptx
@@ -3603,11 +3603,156 @@
           </a:prstGeom>
         </p:spPr>
       </p:pic>
+      <p:pic>
+        <p:nvPicPr>
+          <p:cNvPr id="19" name="pronunciation.mp3">
+            <a:hlinkClick r:id="" action="ppaction://media"/>
+          </p:cNvPr>
+          <p:cNvPicPr>
+            <a:picLocks noChangeAspect="1"/>
+          </p:cNvPicPr>
+          <p:nvPr>
+            <a:videoFile r:link="rId9"/>
+            <p:extLst>
+              <p:ext uri="{DAA4B4D4-6D71-4841-9C94-3DE7FCFB9230}">
+                <p14:media xmlns:p14="http://schemas.microsoft.com/office/powerpoint/2010/main" r:embed="rId8"/>
+              </p:ext>
+            </p:extLst>
+          </p:nvPr>
+        </p:nvPicPr>
+        <p:blipFill>
+          <a:blip r:embed="rId10"/>
+          <a:stretch>
+            <a:fillRect/>
+          </a:stretch>
+        </p:blipFill>
+        <p:spPr>
+          <a:xfrm>
+            <a:off x="0" y="0"/>
+            <a:ext cx="1" cy="1"/>
+          </a:xfrm>
+          <a:prstGeom prst="rect">
+            <a:avLst/>
+          </a:prstGeom>
+        </p:spPr>
+      </p:pic>
+      <p:pic>
+        <p:nvPicPr>
+          <p:cNvPr id="20" name="pronunciation.mp3">
+            <a:hlinkClick r:id="" action="ppaction://media"/>
+          </p:cNvPr>
+          <p:cNvPicPr>
+            <a:picLocks noChangeAspect="1"/>
+          </p:cNvPicPr>
+          <p:nvPr>
+            <a:videoFile r:link="rId9"/>
+            <p:extLst>
+              <p:ext uri="{DAA4B4D4-6D71-4841-9C94-3DE7FCFB9230}">
+                <p14:media xmlns:p14="http://schemas.microsoft.com/office/powerpoint/2010/main" r:embed="rId8"/>
+              </p:ext>
+            </p:extLst>
+          </p:nvPr>
+        </p:nvPicPr>
+        <p:blipFill>
+          <a:blip r:embed="rId10"/>
+          <a:stretch>
+            <a:fillRect/>
+          </a:stretch>
+        </p:blipFill>
+        <p:spPr>
+          <a:xfrm>
+            <a:off x="0" y="0"/>
+            <a:ext cx="1" cy="1"/>
+          </a:xfrm>
+          <a:prstGeom prst="rect">
+            <a:avLst/>
+          </a:prstGeom>
+        </p:spPr>
+      </p:pic>
+      <p:pic>
+        <p:nvPicPr>
+          <p:cNvPr id="21" name="meaning.mp3">
+            <a:hlinkClick r:id="" action="ppaction://media"/>
+          </p:cNvPr>
+          <p:cNvPicPr>
+            <a:picLocks noChangeAspect="1"/>
+          </p:cNvPicPr>
+          <p:nvPr>
+            <a:videoFile r:link="rId12"/>
+            <p:extLst>
+              <p:ext uri="{DAA4B4D4-6D71-4841-9C94-3DE7FCFB9230}">
+                <p14:media xmlns:p14="http://schemas.microsoft.com/office/powerpoint/2010/main" r:embed="rId11"/>
+              </p:ext>
+            </p:extLst>
+          </p:nvPr>
+        </p:nvPicPr>
+        <p:blipFill>
+          <a:blip r:embed="rId10"/>
+          <a:stretch>
+            <a:fillRect/>
+          </a:stretch>
+        </p:blipFill>
+        <p:spPr>
+          <a:xfrm>
+            <a:off x="0" y="0"/>
+            <a:ext cx="1" cy="1"/>
+          </a:xfrm>
+          <a:prstGeom prst="rect">
+            <a:avLst/>
+          </a:prstGeom>
+        </p:spPr>
+      </p:pic>
     </p:spTree>
   </p:cSld>
   <p:clrMapOvr>
     <a:masterClrMapping/>
   </p:clrMapOvr>
+  <p:timing>
+    <p:tnLst>
+      <p:par>
+        <p:cTn id="1" dur="indefinite" restart="never" nodeType="tmRoot">
+          <p:childTnLst>
+            <p:video>
+              <p:cMediaNode vol="80000">
+                <p:cTn id="2" fill="hold" display="0">
+                  <p:stCondLst>
+                    <p:cond delay="indefinite"/>
+                  </p:stCondLst>
+                </p:cTn>
+                <p:tgtEl>
+                  <p:spTgt spid="19"/>
+                </p:tgtEl>
+              </p:cMediaNode>
+            </p:video>
+            <p:video>
+              <p:cMediaNode vol="80000">
+                <p:cTn id="3" fill="hold" display="0">
+                  <p:stCondLst>
+                    <p:cond delay="indefinite"/>
+                  </p:stCondLst>
+                </p:cTn>
+                <p:tgtEl>
+                  <p:spTgt spid="20"/>
+                </p:tgtEl>
+              </p:cMediaNode>
+            </p:video>
+            <p:video>
+              <p:cMediaNode vol="80000">
+                <p:cTn id="4" fill="hold" display="0">
+                  <p:stCondLst>
+                    <p:cond delay="indefinite"/>
+                  </p:stCondLst>
+                </p:cTn>
+                <p:tgtEl>
+                  <p:spTgt spid="21"/>
+                </p:tgtEl>
+              </p:cMediaNode>
+            </p:video>
+          </p:childTnLst>
+        </p:cTn>
+      </p:par>
+    </p:tnLst>
+  </p:timing>
 </p:sld>
 </file>
 
@@ -4161,11 +4306,66 @@
           </a:prstGeom>
         </p:spPr>
       </p:pic>
+      <p:pic>
+        <p:nvPicPr>
+          <p:cNvPr id="21" name="present_sentence.mp3">
+            <a:hlinkClick r:id="" action="ppaction://media"/>
+          </p:cNvPr>
+          <p:cNvPicPr>
+            <a:picLocks noChangeAspect="1"/>
+          </p:cNvPicPr>
+          <p:nvPr>
+            <a:videoFile r:link="rId8"/>
+            <p:extLst>
+              <p:ext uri="{DAA4B4D4-6D71-4841-9C94-3DE7FCFB9230}">
+                <p14:media xmlns:p14="http://schemas.microsoft.com/office/powerpoint/2010/main" r:embed="rId7"/>
+              </p:ext>
+            </p:extLst>
+          </p:nvPr>
+        </p:nvPicPr>
+        <p:blipFill>
+          <a:blip r:embed="rId9"/>
+          <a:stretch>
+            <a:fillRect/>
+          </a:stretch>
+        </p:blipFill>
+        <p:spPr>
+          <a:xfrm>
+            <a:off x="0" y="0"/>
+            <a:ext cx="1" cy="1"/>
+          </a:xfrm>
+          <a:prstGeom prst="rect">
+            <a:avLst/>
+          </a:prstGeom>
+        </p:spPr>
+      </p:pic>
     </p:spTree>
   </p:cSld>
   <p:clrMapOvr>
     <a:masterClrMapping/>
   </p:clrMapOvr>
+  <p:timing>
+    <p:tnLst>
+      <p:par>
+        <p:cTn id="1" dur="indefinite" restart="never" nodeType="tmRoot">
+          <p:childTnLst>
+            <p:video>
+              <p:cMediaNode vol="80000">
+                <p:cTn id="2" fill="hold" display="0">
+                  <p:stCondLst>
+                    <p:cond delay="indefinite"/>
+                  </p:stCondLst>
+                </p:cTn>
+                <p:tgtEl>
+                  <p:spTgt spid="21"/>
+                </p:tgtEl>
+              </p:cMediaNode>
+            </p:video>
+          </p:childTnLst>
+        </p:cTn>
+      </p:par>
+    </p:tnLst>
+  </p:timing>
 </p:sld>
 </file>
 
@@ -4767,11 +4967,66 @@
           </a:prstGeom>
         </p:spPr>
       </p:pic>
+      <p:pic>
+        <p:nvPicPr>
+          <p:cNvPr id="24" name="present_sentence.mp3">
+            <a:hlinkClick r:id="" action="ppaction://media"/>
+          </p:cNvPr>
+          <p:cNvPicPr>
+            <a:picLocks noChangeAspect="1"/>
+          </p:cNvPicPr>
+          <p:nvPr>
+            <a:videoFile r:link="rId8"/>
+            <p:extLst>
+              <p:ext uri="{DAA4B4D4-6D71-4841-9C94-3DE7FCFB9230}">
+                <p14:media xmlns:p14="http://schemas.microsoft.com/office/powerpoint/2010/main" r:embed="rId7"/>
+              </p:ext>
+            </p:extLst>
+          </p:nvPr>
+        </p:nvPicPr>
+        <p:blipFill>
+          <a:blip r:embed="rId9"/>
+          <a:stretch>
+            <a:fillRect/>
+          </a:stretch>
+        </p:blipFill>
+        <p:spPr>
+          <a:xfrm>
+            <a:off x="0" y="0"/>
+            <a:ext cx="1" cy="1"/>
+          </a:xfrm>
+          <a:prstGeom prst="rect">
+            <a:avLst/>
+          </a:prstGeom>
+        </p:spPr>
+      </p:pic>
     </p:spTree>
   </p:cSld>
   <p:clrMapOvr>
     <a:masterClrMapping/>
   </p:clrMapOvr>
+  <p:timing>
+    <p:tnLst>
+      <p:par>
+        <p:cTn id="1" dur="indefinite" restart="never" nodeType="tmRoot">
+          <p:childTnLst>
+            <p:video>
+              <p:cMediaNode vol="80000">
+                <p:cTn id="2" fill="hold" display="0">
+                  <p:stCondLst>
+                    <p:cond delay="indefinite"/>
+                  </p:stCondLst>
+                </p:cTn>
+                <p:tgtEl>
+                  <p:spTgt spid="24"/>
+                </p:tgtEl>
+              </p:cMediaNode>
+            </p:video>
+          </p:childTnLst>
+        </p:cTn>
+      </p:par>
+    </p:tnLst>
+  </p:timing>
 </p:sld>
 </file>
 
@@ -5421,11 +5676,66 @@
           </a:prstGeom>
         </p:spPr>
       </p:pic>
+      <p:pic>
+        <p:nvPicPr>
+          <p:cNvPr id="22" name="future_sentence.mp3">
+            <a:hlinkClick r:id="" action="ppaction://media"/>
+          </p:cNvPr>
+          <p:cNvPicPr>
+            <a:picLocks noChangeAspect="1"/>
+          </p:cNvPicPr>
+          <p:nvPr>
+            <a:videoFile r:link="rId8"/>
+            <p:extLst>
+              <p:ext uri="{DAA4B4D4-6D71-4841-9C94-3DE7FCFB9230}">
+                <p14:media xmlns:p14="http://schemas.microsoft.com/office/powerpoint/2010/main" r:embed="rId7"/>
+              </p:ext>
+            </p:extLst>
+          </p:nvPr>
+        </p:nvPicPr>
+        <p:blipFill>
+          <a:blip r:embed="rId9"/>
+          <a:stretch>
+            <a:fillRect/>
+          </a:stretch>
+        </p:blipFill>
+        <p:spPr>
+          <a:xfrm>
+            <a:off x="0" y="0"/>
+            <a:ext cx="1" cy="1"/>
+          </a:xfrm>
+          <a:prstGeom prst="rect">
+            <a:avLst/>
+          </a:prstGeom>
+        </p:spPr>
+      </p:pic>
     </p:spTree>
   </p:cSld>
   <p:clrMapOvr>
     <a:masterClrMapping/>
   </p:clrMapOvr>
+  <p:timing>
+    <p:tnLst>
+      <p:par>
+        <p:cTn id="1" dur="indefinite" restart="never" nodeType="tmRoot">
+          <p:childTnLst>
+            <p:video>
+              <p:cMediaNode vol="80000">
+                <p:cTn id="2" fill="hold" display="0">
+                  <p:stCondLst>
+                    <p:cond delay="indefinite"/>
+                  </p:stCondLst>
+                </p:cTn>
+                <p:tgtEl>
+                  <p:spTgt spid="22"/>
+                </p:tgtEl>
+              </p:cMediaNode>
+            </p:video>
+          </p:childTnLst>
+        </p:cTn>
+      </p:par>
+    </p:tnLst>
+  </p:timing>
 </p:sld>
 </file>
 
@@ -6030,6 +6340,39 @@
           </a:prstGeom>
         </p:spPr>
       </p:pic>
+      <p:pic>
+        <p:nvPicPr>
+          <p:cNvPr id="21" name="present_sentence.mp3">
+            <a:hlinkClick r:id="" action="ppaction://media"/>
+          </p:cNvPr>
+          <p:cNvPicPr>
+            <a:picLocks noChangeAspect="1"/>
+          </p:cNvPicPr>
+          <p:nvPr>
+            <a:videoFile r:link="rId9"/>
+            <p:extLst>
+              <p:ext uri="{DAA4B4D4-6D71-4841-9C94-3DE7FCFB9230}">
+                <p14:media xmlns:p14="http://schemas.microsoft.com/office/powerpoint/2010/main" r:embed="rId8"/>
+              </p:ext>
+            </p:extLst>
+          </p:nvPr>
+        </p:nvPicPr>
+        <p:blipFill>
+          <a:blip r:embed="rId10"/>
+          <a:stretch>
+            <a:fillRect/>
+          </a:stretch>
+        </p:blipFill>
+        <p:spPr>
+          <a:xfrm>
+            <a:off x="0" y="0"/>
+            <a:ext cx="1" cy="1"/>
+          </a:xfrm>
+          <a:prstGeom prst="rect">
+            <a:avLst/>
+          </a:prstGeom>
+        </p:spPr>
+      </p:pic>
     </p:spTree>
     <p:extLst>
       <p:ext uri="{BB962C8B-B14F-4D97-AF65-F5344CB8AC3E}">
@@ -6040,6 +6383,28 @@
   <p:clrMapOvr>
     <a:masterClrMapping/>
   </p:clrMapOvr>
+  <p:timing>
+    <p:tnLst>
+      <p:par>
+        <p:cTn id="1" dur="indefinite" restart="never" nodeType="tmRoot">
+          <p:childTnLst>
+            <p:video>
+              <p:cMediaNode vol="80000">
+                <p:cTn id="2" fill="hold" display="0">
+                  <p:stCondLst>
+                    <p:cond delay="indefinite"/>
+                  </p:stCondLst>
+                </p:cTn>
+                <p:tgtEl>
+                  <p:spTgt spid="21"/>
+                </p:tgtEl>
+              </p:cMediaNode>
+            </p:video>
+          </p:childTnLst>
+        </p:cTn>
+      </p:par>
+    </p:tnLst>
+  </p:timing>
 </p:sld>
 </file>
 
@@ -6692,6 +7057,39 @@
           </a:prstGeom>
         </p:spPr>
       </p:pic>
+      <p:pic>
+        <p:nvPicPr>
+          <p:cNvPr id="24" name="present_sentence.mp3">
+            <a:hlinkClick r:id="" action="ppaction://media"/>
+          </p:cNvPr>
+          <p:cNvPicPr>
+            <a:picLocks noChangeAspect="1"/>
+          </p:cNvPicPr>
+          <p:nvPr>
+            <a:videoFile r:link="rId9"/>
+            <p:extLst>
+              <p:ext uri="{DAA4B4D4-6D71-4841-9C94-3DE7FCFB9230}">
+                <p14:media xmlns:p14="http://schemas.microsoft.com/office/powerpoint/2010/main" r:embed="rId8"/>
+              </p:ext>
+            </p:extLst>
+          </p:nvPr>
+        </p:nvPicPr>
+        <p:blipFill>
+          <a:blip r:embed="rId10"/>
+          <a:stretch>
+            <a:fillRect/>
+          </a:stretch>
+        </p:blipFill>
+        <p:spPr>
+          <a:xfrm>
+            <a:off x="0" y="0"/>
+            <a:ext cx="1" cy="1"/>
+          </a:xfrm>
+          <a:prstGeom prst="rect">
+            <a:avLst/>
+          </a:prstGeom>
+        </p:spPr>
+      </p:pic>
     </p:spTree>
     <p:extLst>
       <p:ext uri="{BB962C8B-B14F-4D97-AF65-F5344CB8AC3E}">
@@ -6702,6 +7100,28 @@
   <p:clrMapOvr>
     <a:masterClrMapping/>
   </p:clrMapOvr>
+  <p:timing>
+    <p:tnLst>
+      <p:par>
+        <p:cTn id="1" dur="indefinite" restart="never" nodeType="tmRoot">
+          <p:childTnLst>
+            <p:video>
+              <p:cMediaNode vol="80000">
+                <p:cTn id="2" fill="hold" display="0">
+                  <p:stCondLst>
+                    <p:cond delay="indefinite"/>
+                  </p:stCondLst>
+                </p:cTn>
+                <p:tgtEl>
+                  <p:spTgt spid="24"/>
+                </p:tgtEl>
+              </p:cMediaNode>
+            </p:video>
+          </p:childTnLst>
+        </p:cTn>
+      </p:par>
+    </p:tnLst>
+  </p:timing>
 </p:sld>
 </file>
 
@@ -7402,6 +7822,39 @@
           </a:prstGeom>
         </p:spPr>
       </p:pic>
+      <p:pic>
+        <p:nvPicPr>
+          <p:cNvPr id="22" name="future_sentence.mp3">
+            <a:hlinkClick r:id="" action="ppaction://media"/>
+          </p:cNvPr>
+          <p:cNvPicPr>
+            <a:picLocks noChangeAspect="1"/>
+          </p:cNvPicPr>
+          <p:nvPr>
+            <a:videoFile r:link="rId9"/>
+            <p:extLst>
+              <p:ext uri="{DAA4B4D4-6D71-4841-9C94-3DE7FCFB9230}">
+                <p14:media xmlns:p14="http://schemas.microsoft.com/office/powerpoint/2010/main" r:embed="rId8"/>
+              </p:ext>
+            </p:extLst>
+          </p:nvPr>
+        </p:nvPicPr>
+        <p:blipFill>
+          <a:blip r:embed="rId10"/>
+          <a:stretch>
+            <a:fillRect/>
+          </a:stretch>
+        </p:blipFill>
+        <p:spPr>
+          <a:xfrm>
+            <a:off x="0" y="0"/>
+            <a:ext cx="1" cy="1"/>
+          </a:xfrm>
+          <a:prstGeom prst="rect">
+            <a:avLst/>
+          </a:prstGeom>
+        </p:spPr>
+      </p:pic>
     </p:spTree>
     <p:extLst>
       <p:ext uri="{BB962C8B-B14F-4D97-AF65-F5344CB8AC3E}">
@@ -7412,6 +7865,28 @@
   <p:clrMapOvr>
     <a:masterClrMapping/>
   </p:clrMapOvr>
+  <p:timing>
+    <p:tnLst>
+      <p:par>
+        <p:cTn id="1" dur="indefinite" restart="never" nodeType="tmRoot">
+          <p:childTnLst>
+            <p:video>
+              <p:cMediaNode vol="80000">
+                <p:cTn id="2" fill="hold" display="0">
+                  <p:stCondLst>
+                    <p:cond delay="indefinite"/>
+                  </p:stCondLst>
+                </p:cTn>
+                <p:tgtEl>
+                  <p:spTgt spid="22"/>
+                </p:tgtEl>
+              </p:cMediaNode>
+            </p:video>
+          </p:childTnLst>
+        </p:cTn>
+      </p:par>
+    </p:tnLst>
+  </p:timing>
 </p:sld>
 </file>
 
@@ -7901,11 +8376,156 @@
           </a:prstGeom>
         </p:spPr>
       </p:pic>
+      <p:pic>
+        <p:nvPicPr>
+          <p:cNvPr id="19" name="pronunciation.mp3">
+            <a:hlinkClick r:id="" action="ppaction://media"/>
+          </p:cNvPr>
+          <p:cNvPicPr>
+            <a:picLocks noChangeAspect="1"/>
+          </p:cNvPicPr>
+          <p:nvPr>
+            <a:videoFile r:link="rId8"/>
+            <p:extLst>
+              <p:ext uri="{DAA4B4D4-6D71-4841-9C94-3DE7FCFB9230}">
+                <p14:media xmlns:p14="http://schemas.microsoft.com/office/powerpoint/2010/main" r:embed="rId7"/>
+              </p:ext>
+            </p:extLst>
+          </p:nvPr>
+        </p:nvPicPr>
+        <p:blipFill>
+          <a:blip r:embed="rId9"/>
+          <a:stretch>
+            <a:fillRect/>
+          </a:stretch>
+        </p:blipFill>
+        <p:spPr>
+          <a:xfrm>
+            <a:off x="0" y="0"/>
+            <a:ext cx="1" cy="1"/>
+          </a:xfrm>
+          <a:prstGeom prst="rect">
+            <a:avLst/>
+          </a:prstGeom>
+        </p:spPr>
+      </p:pic>
+      <p:pic>
+        <p:nvPicPr>
+          <p:cNvPr id="20" name="pronunciation.mp3">
+            <a:hlinkClick r:id="" action="ppaction://media"/>
+          </p:cNvPr>
+          <p:cNvPicPr>
+            <a:picLocks noChangeAspect="1"/>
+          </p:cNvPicPr>
+          <p:nvPr>
+            <a:videoFile r:link="rId8"/>
+            <p:extLst>
+              <p:ext uri="{DAA4B4D4-6D71-4841-9C94-3DE7FCFB9230}">
+                <p14:media xmlns:p14="http://schemas.microsoft.com/office/powerpoint/2010/main" r:embed="rId7"/>
+              </p:ext>
+            </p:extLst>
+          </p:nvPr>
+        </p:nvPicPr>
+        <p:blipFill>
+          <a:blip r:embed="rId9"/>
+          <a:stretch>
+            <a:fillRect/>
+          </a:stretch>
+        </p:blipFill>
+        <p:spPr>
+          <a:xfrm>
+            <a:off x="0" y="0"/>
+            <a:ext cx="1" cy="1"/>
+          </a:xfrm>
+          <a:prstGeom prst="rect">
+            <a:avLst/>
+          </a:prstGeom>
+        </p:spPr>
+      </p:pic>
+      <p:pic>
+        <p:nvPicPr>
+          <p:cNvPr id="21" name="meaning.mp3">
+            <a:hlinkClick r:id="" action="ppaction://media"/>
+          </p:cNvPr>
+          <p:cNvPicPr>
+            <a:picLocks noChangeAspect="1"/>
+          </p:cNvPicPr>
+          <p:nvPr>
+            <a:videoFile r:link="rId11"/>
+            <p:extLst>
+              <p:ext uri="{DAA4B4D4-6D71-4841-9C94-3DE7FCFB9230}">
+                <p14:media xmlns:p14="http://schemas.microsoft.com/office/powerpoint/2010/main" r:embed="rId10"/>
+              </p:ext>
+            </p:extLst>
+          </p:nvPr>
+        </p:nvPicPr>
+        <p:blipFill>
+          <a:blip r:embed="rId9"/>
+          <a:stretch>
+            <a:fillRect/>
+          </a:stretch>
+        </p:blipFill>
+        <p:spPr>
+          <a:xfrm>
+            <a:off x="0" y="0"/>
+            <a:ext cx="1" cy="1"/>
+          </a:xfrm>
+          <a:prstGeom prst="rect">
+            <a:avLst/>
+          </a:prstGeom>
+        </p:spPr>
+      </p:pic>
     </p:spTree>
   </p:cSld>
   <p:clrMapOvr>
     <a:masterClrMapping/>
   </p:clrMapOvr>
+  <p:timing>
+    <p:tnLst>
+      <p:par>
+        <p:cTn id="1" dur="indefinite" restart="never" nodeType="tmRoot">
+          <p:childTnLst>
+            <p:video>
+              <p:cMediaNode vol="80000">
+                <p:cTn id="2" fill="hold" display="0">
+                  <p:stCondLst>
+                    <p:cond delay="indefinite"/>
+                  </p:stCondLst>
+                </p:cTn>
+                <p:tgtEl>
+                  <p:spTgt spid="19"/>
+                </p:tgtEl>
+              </p:cMediaNode>
+            </p:video>
+            <p:video>
+              <p:cMediaNode vol="80000">
+                <p:cTn id="3" fill="hold" display="0">
+                  <p:stCondLst>
+                    <p:cond delay="indefinite"/>
+                  </p:stCondLst>
+                </p:cTn>
+                <p:tgtEl>
+                  <p:spTgt spid="20"/>
+                </p:tgtEl>
+              </p:cMediaNode>
+            </p:video>
+            <p:video>
+              <p:cMediaNode vol="80000">
+                <p:cTn id="4" fill="hold" display="0">
+                  <p:stCondLst>
+                    <p:cond delay="indefinite"/>
+                  </p:stCondLst>
+                </p:cTn>
+                <p:tgtEl>
+                  <p:spTgt spid="21"/>
+                </p:tgtEl>
+              </p:cMediaNode>
+            </p:video>
+          </p:childTnLst>
+        </p:cTn>
+      </p:par>
+    </p:tnLst>
+  </p:timing>
 </p:sld>
 </file>
 
@@ -8459,11 +9079,66 @@
           </a:prstGeom>
         </p:spPr>
       </p:pic>
+      <p:pic>
+        <p:nvPicPr>
+          <p:cNvPr id="21" name="present_sentence.mp3">
+            <a:hlinkClick r:id="" action="ppaction://media"/>
+          </p:cNvPr>
+          <p:cNvPicPr>
+            <a:picLocks noChangeAspect="1"/>
+          </p:cNvPicPr>
+          <p:nvPr>
+            <a:videoFile r:link="rId8"/>
+            <p:extLst>
+              <p:ext uri="{DAA4B4D4-6D71-4841-9C94-3DE7FCFB9230}">
+                <p14:media xmlns:p14="http://schemas.microsoft.com/office/powerpoint/2010/main" r:embed="rId7"/>
+              </p:ext>
+            </p:extLst>
+          </p:nvPr>
+        </p:nvPicPr>
+        <p:blipFill>
+          <a:blip r:embed="rId9"/>
+          <a:stretch>
+            <a:fillRect/>
+          </a:stretch>
+        </p:blipFill>
+        <p:spPr>
+          <a:xfrm>
+            <a:off x="0" y="0"/>
+            <a:ext cx="1" cy="1"/>
+          </a:xfrm>
+          <a:prstGeom prst="rect">
+            <a:avLst/>
+          </a:prstGeom>
+        </p:spPr>
+      </p:pic>
     </p:spTree>
   </p:cSld>
   <p:clrMapOvr>
     <a:masterClrMapping/>
   </p:clrMapOvr>
+  <p:timing>
+    <p:tnLst>
+      <p:par>
+        <p:cTn id="1" dur="indefinite" restart="never" nodeType="tmRoot">
+          <p:childTnLst>
+            <p:video>
+              <p:cMediaNode vol="80000">
+                <p:cTn id="2" fill="hold" display="0">
+                  <p:stCondLst>
+                    <p:cond delay="indefinite"/>
+                  </p:stCondLst>
+                </p:cTn>
+                <p:tgtEl>
+                  <p:spTgt spid="21"/>
+                </p:tgtEl>
+              </p:cMediaNode>
+            </p:video>
+          </p:childTnLst>
+        </p:cTn>
+      </p:par>
+    </p:tnLst>
+  </p:timing>
 </p:sld>
 </file>
 
@@ -9065,11 +9740,66 @@
           </a:prstGeom>
         </p:spPr>
       </p:pic>
+      <p:pic>
+        <p:nvPicPr>
+          <p:cNvPr id="24" name="present_sentence.mp3">
+            <a:hlinkClick r:id="" action="ppaction://media"/>
+          </p:cNvPr>
+          <p:cNvPicPr>
+            <a:picLocks noChangeAspect="1"/>
+          </p:cNvPicPr>
+          <p:nvPr>
+            <a:videoFile r:link="rId8"/>
+            <p:extLst>
+              <p:ext uri="{DAA4B4D4-6D71-4841-9C94-3DE7FCFB9230}">
+                <p14:media xmlns:p14="http://schemas.microsoft.com/office/powerpoint/2010/main" r:embed="rId7"/>
+              </p:ext>
+            </p:extLst>
+          </p:nvPr>
+        </p:nvPicPr>
+        <p:blipFill>
+          <a:blip r:embed="rId9"/>
+          <a:stretch>
+            <a:fillRect/>
+          </a:stretch>
+        </p:blipFill>
+        <p:spPr>
+          <a:xfrm>
+            <a:off x="0" y="0"/>
+            <a:ext cx="1" cy="1"/>
+          </a:xfrm>
+          <a:prstGeom prst="rect">
+            <a:avLst/>
+          </a:prstGeom>
+        </p:spPr>
+      </p:pic>
     </p:spTree>
   </p:cSld>
   <p:clrMapOvr>
     <a:masterClrMapping/>
   </p:clrMapOvr>
+  <p:timing>
+    <p:tnLst>
+      <p:par>
+        <p:cTn id="1" dur="indefinite" restart="never" nodeType="tmRoot">
+          <p:childTnLst>
+            <p:video>
+              <p:cMediaNode vol="80000">
+                <p:cTn id="2" fill="hold" display="0">
+                  <p:stCondLst>
+                    <p:cond delay="indefinite"/>
+                  </p:stCondLst>
+                </p:cTn>
+                <p:tgtEl>
+                  <p:spTgt spid="24"/>
+                </p:tgtEl>
+              </p:cMediaNode>
+            </p:video>
+          </p:childTnLst>
+        </p:cTn>
+      </p:par>
+    </p:tnLst>
+  </p:timing>
 </p:sld>
 </file>
 
@@ -9719,11 +10449,66 @@
           </a:prstGeom>
         </p:spPr>
       </p:pic>
+      <p:pic>
+        <p:nvPicPr>
+          <p:cNvPr id="22" name="future_sentence.mp3">
+            <a:hlinkClick r:id="" action="ppaction://media"/>
+          </p:cNvPr>
+          <p:cNvPicPr>
+            <a:picLocks noChangeAspect="1"/>
+          </p:cNvPicPr>
+          <p:nvPr>
+            <a:videoFile r:link="rId8"/>
+            <p:extLst>
+              <p:ext uri="{DAA4B4D4-6D71-4841-9C94-3DE7FCFB9230}">
+                <p14:media xmlns:p14="http://schemas.microsoft.com/office/powerpoint/2010/main" r:embed="rId7"/>
+              </p:ext>
+            </p:extLst>
+          </p:nvPr>
+        </p:nvPicPr>
+        <p:blipFill>
+          <a:blip r:embed="rId9"/>
+          <a:stretch>
+            <a:fillRect/>
+          </a:stretch>
+        </p:blipFill>
+        <p:spPr>
+          <a:xfrm>
+            <a:off x="0" y="0"/>
+            <a:ext cx="1" cy="1"/>
+          </a:xfrm>
+          <a:prstGeom prst="rect">
+            <a:avLst/>
+          </a:prstGeom>
+        </p:spPr>
+      </p:pic>
     </p:spTree>
   </p:cSld>
   <p:clrMapOvr>
     <a:masterClrMapping/>
   </p:clrMapOvr>
+  <p:timing>
+    <p:tnLst>
+      <p:par>
+        <p:cTn id="1" dur="indefinite" restart="never" nodeType="tmRoot">
+          <p:childTnLst>
+            <p:video>
+              <p:cMediaNode vol="80000">
+                <p:cTn id="2" fill="hold" display="0">
+                  <p:stCondLst>
+                    <p:cond delay="indefinite"/>
+                  </p:stCondLst>
+                </p:cTn>
+                <p:tgtEl>
+                  <p:spTgt spid="22"/>
+                </p:tgtEl>
+              </p:cMediaNode>
+            </p:video>
+          </p:childTnLst>
+        </p:cTn>
+      </p:par>
+    </p:tnLst>
+  </p:timing>
 </p:sld>
 </file>
 
@@ -10213,11 +10998,156 @@
           </a:prstGeom>
         </p:spPr>
       </p:pic>
+      <p:pic>
+        <p:nvPicPr>
+          <p:cNvPr id="19" name="pronunciation.mp3">
+            <a:hlinkClick r:id="" action="ppaction://media"/>
+          </p:cNvPr>
+          <p:cNvPicPr>
+            <a:picLocks noChangeAspect="1"/>
+          </p:cNvPicPr>
+          <p:nvPr>
+            <a:videoFile r:link="rId8"/>
+            <p:extLst>
+              <p:ext uri="{DAA4B4D4-6D71-4841-9C94-3DE7FCFB9230}">
+                <p14:media xmlns:p14="http://schemas.microsoft.com/office/powerpoint/2010/main" r:embed="rId7"/>
+              </p:ext>
+            </p:extLst>
+          </p:nvPr>
+        </p:nvPicPr>
+        <p:blipFill>
+          <a:blip r:embed="rId9"/>
+          <a:stretch>
+            <a:fillRect/>
+          </a:stretch>
+        </p:blipFill>
+        <p:spPr>
+          <a:xfrm>
+            <a:off x="0" y="0"/>
+            <a:ext cx="1" cy="1"/>
+          </a:xfrm>
+          <a:prstGeom prst="rect">
+            <a:avLst/>
+          </a:prstGeom>
+        </p:spPr>
+      </p:pic>
+      <p:pic>
+        <p:nvPicPr>
+          <p:cNvPr id="20" name="pronunciation.mp3">
+            <a:hlinkClick r:id="" action="ppaction://media"/>
+          </p:cNvPr>
+          <p:cNvPicPr>
+            <a:picLocks noChangeAspect="1"/>
+          </p:cNvPicPr>
+          <p:nvPr>
+            <a:videoFile r:link="rId8"/>
+            <p:extLst>
+              <p:ext uri="{DAA4B4D4-6D71-4841-9C94-3DE7FCFB9230}">
+                <p14:media xmlns:p14="http://schemas.microsoft.com/office/powerpoint/2010/main" r:embed="rId7"/>
+              </p:ext>
+            </p:extLst>
+          </p:nvPr>
+        </p:nvPicPr>
+        <p:blipFill>
+          <a:blip r:embed="rId9"/>
+          <a:stretch>
+            <a:fillRect/>
+          </a:stretch>
+        </p:blipFill>
+        <p:spPr>
+          <a:xfrm>
+            <a:off x="0" y="0"/>
+            <a:ext cx="1" cy="1"/>
+          </a:xfrm>
+          <a:prstGeom prst="rect">
+            <a:avLst/>
+          </a:prstGeom>
+        </p:spPr>
+      </p:pic>
+      <p:pic>
+        <p:nvPicPr>
+          <p:cNvPr id="21" name="meaning.mp3">
+            <a:hlinkClick r:id="" action="ppaction://media"/>
+          </p:cNvPr>
+          <p:cNvPicPr>
+            <a:picLocks noChangeAspect="1"/>
+          </p:cNvPicPr>
+          <p:nvPr>
+            <a:videoFile r:link="rId11"/>
+            <p:extLst>
+              <p:ext uri="{DAA4B4D4-6D71-4841-9C94-3DE7FCFB9230}">
+                <p14:media xmlns:p14="http://schemas.microsoft.com/office/powerpoint/2010/main" r:embed="rId10"/>
+              </p:ext>
+            </p:extLst>
+          </p:nvPr>
+        </p:nvPicPr>
+        <p:blipFill>
+          <a:blip r:embed="rId9"/>
+          <a:stretch>
+            <a:fillRect/>
+          </a:stretch>
+        </p:blipFill>
+        <p:spPr>
+          <a:xfrm>
+            <a:off x="0" y="0"/>
+            <a:ext cx="1" cy="1"/>
+          </a:xfrm>
+          <a:prstGeom prst="rect">
+            <a:avLst/>
+          </a:prstGeom>
+        </p:spPr>
+      </p:pic>
     </p:spTree>
   </p:cSld>
   <p:clrMapOvr>
     <a:masterClrMapping/>
   </p:clrMapOvr>
+  <p:timing>
+    <p:tnLst>
+      <p:par>
+        <p:cTn id="1" dur="indefinite" restart="never" nodeType="tmRoot">
+          <p:childTnLst>
+            <p:video>
+              <p:cMediaNode vol="80000">
+                <p:cTn id="2" fill="hold" display="0">
+                  <p:stCondLst>
+                    <p:cond delay="indefinite"/>
+                  </p:stCondLst>
+                </p:cTn>
+                <p:tgtEl>
+                  <p:spTgt spid="19"/>
+                </p:tgtEl>
+              </p:cMediaNode>
+            </p:video>
+            <p:video>
+              <p:cMediaNode vol="80000">
+                <p:cTn id="3" fill="hold" display="0">
+                  <p:stCondLst>
+                    <p:cond delay="indefinite"/>
+                  </p:stCondLst>
+                </p:cTn>
+                <p:tgtEl>
+                  <p:spTgt spid="20"/>
+                </p:tgtEl>
+              </p:cMediaNode>
+            </p:video>
+            <p:video>
+              <p:cMediaNode vol="80000">
+                <p:cTn id="4" fill="hold" display="0">
+                  <p:stCondLst>
+                    <p:cond delay="indefinite"/>
+                  </p:stCondLst>
+                </p:cTn>
+                <p:tgtEl>
+                  <p:spTgt spid="21"/>
+                </p:tgtEl>
+              </p:cMediaNode>
+            </p:video>
+          </p:childTnLst>
+        </p:cTn>
+      </p:par>
+    </p:tnLst>
+  </p:timing>
 </p:sld>
 </file>
 

</xml_diff>